<commit_message>
Redesign architecture diagram slide for legibility
Old: five boxes scattered across two rows with diagonal arrows and tiny
floating labels — hard to read at glance.

New: clean left-to-right pipeline.
- Five evenly-spaced boxes at y=2.35: Orchestrator → Red Team → Target
  → Judge → Documentation, each 2.36" wide x 2.00" tall
- 18pt bold name, 11pt italic role subtitle, 12pt model, 11pt trust
- Color-coded per role (navy / red / gray / green / purple)
- Four numbered arrows (1-4) between adjacent boxes with circular navy
  badges above and bold labels below
- One dashed feedback arrow (5) loops from Judge down, across, and back
  up into Orchestrator — "verdicts + coverage feedback → next campaign"
- Substrate bar at the bottom calls out Postgres + Langfuse + allowlist
</commit_message>
<xml_diff>
--- a/ARCHITECTURE_DEFENSE.pptx
+++ b/ARCHITECTURE_DEFENSE.pptx
@@ -6139,24 +6139,59 @@
       </p:sp>
       <p:sp>
         <p:nvSpPr>
-          <p:cNvPr id="4" name="Rounded Rectangle 3"/>
+          <p:cNvPr id="4" name="TextBox 3"/>
+          <p:cNvSpPr txBox="1"/>
+          <p:nvPr/>
+        </p:nvSpPr>
+        <p:spPr>
+          <a:xfrm>
+            <a:off x="457200" y="1005840"/>
+            <a:ext cx="11247120" cy="365760"/>
+          </a:xfrm>
+          <a:prstGeom prst="rect">
+            <a:avLst/>
+          </a:prstGeom>
+          <a:noFill/>
+        </p:spPr>
+        <p:txBody>
+          <a:bodyPr wrap="none">
+            <a:spAutoFit/>
+          </a:bodyPr>
+          <a:lstStyle/>
+          <a:p>
+            <a:pPr>
+              <a:defRPr sz="1500">
+                <a:solidFill>
+                  <a:srgbClr val="555555"/>
+                </a:solidFill>
+              </a:defRPr>
+            </a:pPr>
+            <a:r>
+              <a:t>Five roles, three model families. Attacker and Judge are structurally independent.</a:t>
+            </a:r>
+          </a:p>
+        </p:txBody>
+      </p:sp>
+      <p:sp>
+        <p:nvSpPr>
+          <p:cNvPr id="5" name="Rounded Rectangle 4"/>
           <p:cNvSpPr/>
           <p:nvPr/>
         </p:nvSpPr>
         <p:spPr>
           <a:xfrm>
-            <a:off x="548640" y="1188720"/>
-            <a:ext cx="2468880" cy="1280160"/>
+            <a:off x="411480" y="2148840"/>
+            <a:ext cx="2157984" cy="1828800"/>
           </a:xfrm>
           <a:prstGeom prst="roundRect">
             <a:avLst/>
           </a:prstGeom>
           <a:solidFill>
-            <a:srgbClr val="2E4A6E"/>
+            <a:srgbClr val="1F3A5F"/>
           </a:solidFill>
           <a:ln>
             <a:solidFill>
-              <a:srgbClr val="1A2B4C"/>
+              <a:srgbClr val="1F3A5F"/>
             </a:solidFill>
           </a:ln>
         </p:spPr>
@@ -6175,11 +6210,14 @@
           </a:fontRef>
         </p:style>
         <p:txBody>
-          <a:bodyPr rtlCol="0" anchor="ctr" wrap="square"/>
+          <a:bodyPr rtlCol="0" anchor="ctr" wrap="square" lIns="109728" rIns="109728" tIns="128016" bIns="128016"/>
           <a:lstStyle/>
           <a:p>
             <a:pPr algn="ctr">
-              <a:defRPr sz="1600" b="1">
+              <a:spcAft>
+                <a:spcPts val="200"/>
+              </a:spcAft>
+              <a:defRPr sz="1800" b="1">
                 <a:solidFill>
                   <a:srgbClr val="FFFFFF"/>
                 </a:solidFill>
@@ -6187,6 +6225,36 @@
             </a:pPr>
             <a:r>
               <a:t>Orchestrator</a:t>
+            </a:r>
+          </a:p>
+          <a:p>
+            <a:pPr algn="ctr">
+              <a:spcAft>
+                <a:spcPts val="800"/>
+              </a:spcAft>
+              <a:defRPr sz="1100" i="1">
+                <a:solidFill>
+                  <a:srgbClr val="FFFFFF"/>
+                </a:solidFill>
+              </a:defRPr>
+            </a:pPr>
+            <a:r>
+              <a:t>what to test next</a:t>
+            </a:r>
+          </a:p>
+          <a:p>
+            <a:pPr algn="ctr">
+              <a:spcAft>
+                <a:spcPts val="400"/>
+              </a:spcAft>
+              <a:defRPr sz="1200" b="1">
+                <a:solidFill>
+                  <a:srgbClr val="FFFFFF"/>
+                </a:solidFill>
+              </a:defRPr>
+            </a:pPr>
+            <a:r>
+              <a:t>Sonnet 4.6</a:t>
             </a:r>
           </a:p>
           <a:p>
@@ -6198,18 +6266,6 @@
               </a:defRPr>
             </a:pPr>
             <a:r>
-              <a:t>Claude Sonnet 4.6</a:t>
-            </a:r>
-          </a:p>
-          <a:p>
-            <a:pPr algn="ctr">
-              <a:defRPr sz="1000">
-                <a:solidFill>
-                  <a:srgbClr val="FFFFFF"/>
-                </a:solidFill>
-              </a:defRPr>
-            </a:pPr>
-            <a:r>
               <a:t>trust: high</a:t>
             </a:r>
           </a:p>
@@ -6217,14 +6273,14 @@
       </p:sp>
       <p:sp>
         <p:nvSpPr>
-          <p:cNvPr id="5" name="Rounded Rectangle 4"/>
+          <p:cNvPr id="6" name="Rounded Rectangle 5"/>
           <p:cNvSpPr/>
           <p:nvPr/>
         </p:nvSpPr>
         <p:spPr>
           <a:xfrm>
-            <a:off x="3657600" y="1188720"/>
-            <a:ext cx="2468880" cy="1280160"/>
+            <a:off x="2980944" y="2148840"/>
+            <a:ext cx="2157984" cy="1828800"/>
           </a:xfrm>
           <a:prstGeom prst="roundRect">
             <a:avLst/>
@@ -6234,7 +6290,7 @@
           </a:solidFill>
           <a:ln>
             <a:solidFill>
-              <a:srgbClr val="1A2B4C"/>
+              <a:srgbClr val="C53A3A"/>
             </a:solidFill>
           </a:ln>
         </p:spPr>
@@ -6253,11 +6309,14 @@
           </a:fontRef>
         </p:style>
         <p:txBody>
-          <a:bodyPr rtlCol="0" anchor="ctr" wrap="square"/>
+          <a:bodyPr rtlCol="0" anchor="ctr" wrap="square" lIns="109728" rIns="109728" tIns="128016" bIns="128016"/>
           <a:lstStyle/>
           <a:p>
             <a:pPr algn="ctr">
-              <a:defRPr sz="1600" b="1">
+              <a:spcAft>
+                <a:spcPts val="200"/>
+              </a:spcAft>
+              <a:defRPr sz="1800" b="1">
                 <a:solidFill>
                   <a:srgbClr val="FFFFFF"/>
                 </a:solidFill>
@@ -6265,6 +6324,40 @@
             </a:pPr>
             <a:r>
               <a:t>Red Team</a:t>
+            </a:r>
+          </a:p>
+          <a:p>
+            <a:pPr algn="ctr">
+              <a:spcAft>
+                <a:spcPts val="800"/>
+              </a:spcAft>
+              <a:defRPr sz="1100" i="1">
+                <a:solidFill>
+                  <a:srgbClr val="FFFFFF"/>
+                </a:solidFill>
+              </a:defRPr>
+            </a:pPr>
+            <a:r>
+              <a:t>generates + mutates</a:t>
+            </a:r>
+          </a:p>
+          <a:p>
+            <a:pPr algn="ctr">
+              <a:spcAft>
+                <a:spcPts val="400"/>
+              </a:spcAft>
+              <a:defRPr sz="1200" b="1">
+                <a:solidFill>
+                  <a:srgbClr val="FFFFFF"/>
+                </a:solidFill>
+              </a:defRPr>
+            </a:pPr>
+            <a:r>
+              <a:t>huihui-ai 70B abl.</a:t>
+            </a:r>
+            <a:br/>
+            <a:r>
+              <a:t>+ DeepSeek-R1</a:t>
             </a:r>
           </a:p>
           <a:p>
@@ -6276,22 +6369,6 @@
               </a:defRPr>
             </a:pPr>
             <a:r>
-              <a:t>huihui-ai L3.3-70B-abl. (RunPod)</a:t>
-            </a:r>
-            <a:br/>
-            <a:r>
-              <a:t>DeepSeek-R1 escalation</a:t>
-            </a:r>
-          </a:p>
-          <a:p>
-            <a:pPr algn="ctr">
-              <a:defRPr sz="1000">
-                <a:solidFill>
-                  <a:srgbClr val="FFFFFF"/>
-                </a:solidFill>
-              </a:defRPr>
-            </a:pPr>
-            <a:r>
               <a:t>trust: low</a:t>
             </a:r>
           </a:p>
@@ -6299,24 +6376,24 @@
       </p:sp>
       <p:sp>
         <p:nvSpPr>
-          <p:cNvPr id="6" name="Rounded Rectangle 5"/>
+          <p:cNvPr id="7" name="Rounded Rectangle 6"/>
           <p:cNvSpPr/>
           <p:nvPr/>
         </p:nvSpPr>
         <p:spPr>
           <a:xfrm>
-            <a:off x="8778240" y="1188720"/>
-            <a:ext cx="2468880" cy="1280160"/>
+            <a:off x="5550408" y="2148840"/>
+            <a:ext cx="2157984" cy="1828800"/>
           </a:xfrm>
           <a:prstGeom prst="roundRect">
             <a:avLst/>
           </a:prstGeom>
           <a:solidFill>
-            <a:srgbClr val="555555"/>
+            <a:srgbClr val="4A5568"/>
           </a:solidFill>
           <a:ln>
             <a:solidFill>
-              <a:srgbClr val="1A2B4C"/>
+              <a:srgbClr val="4A5568"/>
             </a:solidFill>
           </a:ln>
         </p:spPr>
@@ -6335,18 +6412,55 @@
           </a:fontRef>
         </p:style>
         <p:txBody>
-          <a:bodyPr rtlCol="0" anchor="ctr" wrap="square"/>
+          <a:bodyPr rtlCol="0" anchor="ctr" wrap="square" lIns="109728" rIns="109728" tIns="128016" bIns="128016"/>
           <a:lstStyle/>
           <a:p>
             <a:pPr algn="ctr">
-              <a:defRPr sz="1600" b="1">
+              <a:spcAft>
+                <a:spcPts val="200"/>
+              </a:spcAft>
+              <a:defRPr sz="1800" b="1">
                 <a:solidFill>
                   <a:srgbClr val="FFFFFF"/>
                 </a:solidFill>
               </a:defRPr>
             </a:pPr>
             <a:r>
-              <a:t>Target: Clinical Co-Pilot</a:t>
+              <a:t>Target</a:t>
+            </a:r>
+          </a:p>
+          <a:p>
+            <a:pPr algn="ctr">
+              <a:spcAft>
+                <a:spcPts val="800"/>
+              </a:spcAft>
+              <a:defRPr sz="1100" i="1">
+                <a:solidFill>
+                  <a:srgbClr val="FFFFFF"/>
+                </a:solidFill>
+              </a:defRPr>
+            </a:pPr>
+            <a:r>
+              <a:t>system under test</a:t>
+            </a:r>
+          </a:p>
+          <a:p>
+            <a:pPr algn="ctr">
+              <a:spcAft>
+                <a:spcPts val="400"/>
+              </a:spcAft>
+              <a:defRPr sz="1200" b="1">
+                <a:solidFill>
+                  <a:srgbClr val="FFFFFF"/>
+                </a:solidFill>
+              </a:defRPr>
+            </a:pPr>
+            <a:r>
+              <a:t>Co-Pilot</a:t>
+            </a:r>
+            <a:br/>
+            <a:r>
+              <a:t>(Sonnet 4.6)</a:t>
             </a:r>
           </a:p>
           <a:p>
@@ -6358,22 +6472,6 @@
               </a:defRPr>
             </a:pPr>
             <a:r>
-              <a:t>Claude Sonnet 4.6</a:t>
-            </a:r>
-            <a:br/>
-            <a:r>
-              <a:t>(deployed on Railway)</a:t>
-            </a:r>
-          </a:p>
-          <a:p>
-            <a:pPr algn="ctr">
-              <a:defRPr sz="1000">
-                <a:solidFill>
-                  <a:srgbClr val="FFFFFF"/>
-                </a:solidFill>
-              </a:defRPr>
-            </a:pPr>
-            <a:r>
               <a:t>trust: n/a</a:t>
             </a:r>
           </a:p>
@@ -6381,14 +6479,14 @@
       </p:sp>
       <p:sp>
         <p:nvSpPr>
-          <p:cNvPr id="7" name="Rounded Rectangle 6"/>
+          <p:cNvPr id="8" name="Rounded Rectangle 7"/>
           <p:cNvSpPr/>
           <p:nvPr/>
         </p:nvSpPr>
         <p:spPr>
           <a:xfrm>
-            <a:off x="2103120" y="3749039"/>
-            <a:ext cx="2468880" cy="1280160"/>
+            <a:off x="8119871" y="2148840"/>
+            <a:ext cx="2157984" cy="1828800"/>
           </a:xfrm>
           <a:prstGeom prst="roundRect">
             <a:avLst/>
@@ -6398,7 +6496,7 @@
           </a:solidFill>
           <a:ln>
             <a:solidFill>
-              <a:srgbClr val="1A2B4C"/>
+              <a:srgbClr val="2E6E4A"/>
             </a:solidFill>
           </a:ln>
         </p:spPr>
@@ -6417,11 +6515,14 @@
           </a:fontRef>
         </p:style>
         <p:txBody>
-          <a:bodyPr rtlCol="0" anchor="ctr" wrap="square"/>
+          <a:bodyPr rtlCol="0" anchor="ctr" wrap="square" lIns="109728" rIns="109728" tIns="128016" bIns="128016"/>
           <a:lstStyle/>
           <a:p>
             <a:pPr algn="ctr">
-              <a:defRPr sz="1600" b="1">
+              <a:spcAft>
+                <a:spcPts val="200"/>
+              </a:spcAft>
+              <a:defRPr sz="1800" b="1">
                 <a:solidFill>
                   <a:srgbClr val="FFFFFF"/>
                 </a:solidFill>
@@ -6429,6 +6530,36 @@
             </a:pPr>
             <a:r>
               <a:t>Judge</a:t>
+            </a:r>
+          </a:p>
+          <a:p>
+            <a:pPr algn="ctr">
+              <a:spcAft>
+                <a:spcPts val="800"/>
+              </a:spcAft>
+              <a:defRPr sz="1100" i="1">
+                <a:solidFill>
+                  <a:srgbClr val="FFFFFF"/>
+                </a:solidFill>
+              </a:defRPr>
+            </a:pPr>
+            <a:r>
+              <a:t>scores each attack</a:t>
+            </a:r>
+          </a:p>
+          <a:p>
+            <a:pPr algn="ctr">
+              <a:spcAft>
+                <a:spcPts val="400"/>
+              </a:spcAft>
+              <a:defRPr sz="1200" b="1">
+                <a:solidFill>
+                  <a:srgbClr val="FFFFFF"/>
+                </a:solidFill>
+              </a:defRPr>
+            </a:pPr>
+            <a:r>
+              <a:t>Haiku 4.5</a:t>
             </a:r>
           </a:p>
           <a:p>
@@ -6440,43 +6571,31 @@
               </a:defRPr>
             </a:pPr>
             <a:r>
-              <a:t>Claude Haiku 4.5</a:t>
-            </a:r>
-          </a:p>
-          <a:p>
-            <a:pPr algn="ctr">
-              <a:defRPr sz="1000">
-                <a:solidFill>
-                  <a:srgbClr val="FFFFFF"/>
-                </a:solidFill>
-              </a:defRPr>
-            </a:pPr>
-            <a:r>
-              <a:t>trust: med-high</a:t>
-            </a:r>
-          </a:p>
-        </p:txBody>
-      </p:sp>
-      <p:sp>
-        <p:nvSpPr>
-          <p:cNvPr id="8" name="Rounded Rectangle 7"/>
+              <a:t>trust: med-hi</a:t>
+            </a:r>
+          </a:p>
+        </p:txBody>
+      </p:sp>
+      <p:sp>
+        <p:nvSpPr>
+          <p:cNvPr id="9" name="Rounded Rectangle 8"/>
           <p:cNvSpPr/>
           <p:nvPr/>
         </p:nvSpPr>
         <p:spPr>
           <a:xfrm>
-            <a:off x="6400800" y="3749039"/>
-            <a:ext cx="2468880" cy="1280160"/>
+            <a:off x="10689336" y="2148840"/>
+            <a:ext cx="2157984" cy="1828800"/>
           </a:xfrm>
           <a:prstGeom prst="roundRect">
             <a:avLst/>
           </a:prstGeom>
           <a:solidFill>
-            <a:srgbClr val="4A2E6E"/>
+            <a:srgbClr val="6E3A8E"/>
           </a:solidFill>
           <a:ln>
             <a:solidFill>
-              <a:srgbClr val="1A2B4C"/>
+              <a:srgbClr val="6E3A8E"/>
             </a:solidFill>
           </a:ln>
         </p:spPr>
@@ -6495,11 +6614,14 @@
           </a:fontRef>
         </p:style>
         <p:txBody>
-          <a:bodyPr rtlCol="0" anchor="ctr" wrap="square"/>
+          <a:bodyPr rtlCol="0" anchor="ctr" wrap="square" lIns="109728" rIns="109728" tIns="128016" bIns="128016"/>
           <a:lstStyle/>
           <a:p>
             <a:pPr algn="ctr">
-              <a:defRPr sz="1600" b="1">
+              <a:spcAft>
+                <a:spcPts val="200"/>
+              </a:spcAft>
+              <a:defRPr sz="1800" b="1">
                 <a:solidFill>
                   <a:srgbClr val="FFFFFF"/>
                 </a:solidFill>
@@ -6507,6 +6629,36 @@
             </a:pPr>
             <a:r>
               <a:t>Documentation</a:t>
+            </a:r>
+          </a:p>
+          <a:p>
+            <a:pPr algn="ctr">
+              <a:spcAft>
+                <a:spcPts val="800"/>
+              </a:spcAft>
+              <a:defRPr sz="1100" i="1">
+                <a:solidFill>
+                  <a:srgbClr val="FFFFFF"/>
+                </a:solidFill>
+              </a:defRPr>
+            </a:pPr>
+            <a:r>
+              <a:t>writes findings</a:t>
+            </a:r>
+          </a:p>
+          <a:p>
+            <a:pPr algn="ctr">
+              <a:spcAft>
+                <a:spcPts val="400"/>
+              </a:spcAft>
+              <a:defRPr sz="1200" b="1">
+                <a:solidFill>
+                  <a:srgbClr val="FFFFFF"/>
+                </a:solidFill>
+              </a:defRPr>
+            </a:pPr>
+            <a:r>
+              <a:t>Sonnet 4.6</a:t>
             </a:r>
           </a:p>
           <a:p>
@@ -6518,18 +6670,6 @@
               </a:defRPr>
             </a:pPr>
             <a:r>
-              <a:t>Claude Sonnet 4.6</a:t>
-            </a:r>
-          </a:p>
-          <a:p>
-            <a:pPr algn="ctr">
-              <a:defRPr sz="1000">
-                <a:solidFill>
-                  <a:srgbClr val="FFFFFF"/>
-                </a:solidFill>
-              </a:defRPr>
-            </a:pPr>
-            <a:r>
               <a:t>trust: gated</a:t>
             </a:r>
           </a:p>
@@ -6537,22 +6677,23 @@
       </p:sp>
       <p:cxnSp>
         <p:nvCxnSpPr>
-          <p:cNvPr id="9" name="Connector 8"/>
+          <p:cNvPr id="10" name="Connector 9"/>
           <p:cNvCxnSpPr/>
           <p:nvPr/>
         </p:nvCxnSpPr>
         <p:spPr>
           <a:xfrm>
-            <a:off x="3017520" y="1828800"/>
-            <a:ext cx="640080" cy="0"/>
+            <a:off x="2596896" y="3063240"/>
+            <a:ext cx="356616" cy="0"/>
           </a:xfrm>
           <a:prstGeom prst="line">
             <a:avLst/>
           </a:prstGeom>
-          <a:ln w="25400">
+          <a:ln w="38100">
             <a:solidFill>
               <a:srgbClr val="1A2B4C"/>
             </a:solidFill>
+            <a:tailEnd type="triangle" w="med" len="med"/>
           </a:ln>
         </p:spPr>
         <p:style>
@@ -6572,14 +6713,66 @@
       </p:cxnSp>
       <p:sp>
         <p:nvSpPr>
-          <p:cNvPr id="10" name="TextBox 9"/>
+          <p:cNvPr id="11" name="Oval 10"/>
+          <p:cNvSpPr/>
+          <p:nvPr/>
+        </p:nvSpPr>
+        <p:spPr>
+          <a:xfrm>
+            <a:off x="2647188" y="2350008"/>
+            <a:ext cx="256032" cy="256032"/>
+          </a:xfrm>
+          <a:prstGeom prst="ellipse">
+            <a:avLst/>
+          </a:prstGeom>
+          <a:solidFill>
+            <a:srgbClr val="1A2B4C"/>
+          </a:solidFill>
+          <a:ln>
+            <a:noFill/>
+          </a:ln>
+        </p:spPr>
+        <p:style>
+          <a:lnRef idx="1">
+            <a:schemeClr val="accent1"/>
+          </a:lnRef>
+          <a:fillRef idx="3">
+            <a:schemeClr val="accent1"/>
+          </a:fillRef>
+          <a:effectRef idx="2">
+            <a:schemeClr val="accent1"/>
+          </a:effectRef>
+          <a:fontRef idx="minor">
+            <a:schemeClr val="lt1"/>
+          </a:fontRef>
+        </p:style>
+        <p:txBody>
+          <a:bodyPr rtlCol="0" anchor="ctr" lIns="0" rIns="0" tIns="18288" bIns="0"/>
+          <a:lstStyle/>
+          <a:p>
+            <a:pPr algn="ctr">
+              <a:defRPr sz="1000" b="1">
+                <a:solidFill>
+                  <a:srgbClr val="FFFFFF"/>
+                </a:solidFill>
+              </a:defRPr>
+            </a:pPr>
+            <a:r>
+              <a:t>1</a:t>
+            </a:r>
+          </a:p>
+        </p:txBody>
+      </p:sp>
+      <p:sp>
+        <p:nvSpPr>
+          <p:cNvPr id="12" name="TextBox 11"/>
           <p:cNvSpPr txBox="1"/>
           <p:nvPr/>
         </p:nvSpPr>
         <p:spPr>
           <a:xfrm>
-            <a:off x="2423160" y="1664208"/>
-            <a:ext cx="1828800" cy="329184"/>
+            <a:off x="1906524" y="3108960"/>
+            <a:ext cx="1737360" cy="365760"/>
           </a:xfrm>
           <a:prstGeom prst="rect">
             <a:avLst/>
@@ -6593,9 +6786,9 @@
           <a:lstStyle/>
           <a:p>
             <a:pPr algn="ctr">
-              <a:defRPr sz="1000">
-                <a:solidFill>
-                  <a:srgbClr val="555555"/>
+              <a:defRPr sz="1100" b="1">
+                <a:solidFill>
+                  <a:srgbClr val="1A2B4C"/>
                 </a:solidFill>
               </a:defRPr>
             </a:pPr>
@@ -6607,22 +6800,23 @@
       </p:sp>
       <p:cxnSp>
         <p:nvCxnSpPr>
-          <p:cNvPr id="11" name="Connector 10"/>
+          <p:cNvPr id="13" name="Connector 12"/>
           <p:cNvCxnSpPr/>
           <p:nvPr/>
         </p:nvCxnSpPr>
         <p:spPr>
           <a:xfrm>
-            <a:off x="6126480" y="1828800"/>
-            <a:ext cx="2651760" cy="0"/>
+            <a:off x="5166360" y="3063240"/>
+            <a:ext cx="356616" cy="0"/>
           </a:xfrm>
           <a:prstGeom prst="line">
             <a:avLst/>
           </a:prstGeom>
-          <a:ln w="25400">
+          <a:ln w="38100">
             <a:solidFill>
               <a:srgbClr val="1A2B4C"/>
             </a:solidFill>
+            <a:tailEnd type="triangle" w="med" len="med"/>
           </a:ln>
         </p:spPr>
         <p:style>
@@ -6642,14 +6836,66 @@
       </p:cxnSp>
       <p:sp>
         <p:nvSpPr>
-          <p:cNvPr id="12" name="TextBox 11"/>
+          <p:cNvPr id="14" name="Oval 13"/>
+          <p:cNvSpPr/>
+          <p:nvPr/>
+        </p:nvSpPr>
+        <p:spPr>
+          <a:xfrm>
+            <a:off x="5216652" y="2350008"/>
+            <a:ext cx="256032" cy="256032"/>
+          </a:xfrm>
+          <a:prstGeom prst="ellipse">
+            <a:avLst/>
+          </a:prstGeom>
+          <a:solidFill>
+            <a:srgbClr val="1A2B4C"/>
+          </a:solidFill>
+          <a:ln>
+            <a:noFill/>
+          </a:ln>
+        </p:spPr>
+        <p:style>
+          <a:lnRef idx="1">
+            <a:schemeClr val="accent1"/>
+          </a:lnRef>
+          <a:fillRef idx="3">
+            <a:schemeClr val="accent1"/>
+          </a:fillRef>
+          <a:effectRef idx="2">
+            <a:schemeClr val="accent1"/>
+          </a:effectRef>
+          <a:fontRef idx="minor">
+            <a:schemeClr val="lt1"/>
+          </a:fontRef>
+        </p:style>
+        <p:txBody>
+          <a:bodyPr rtlCol="0" anchor="ctr" lIns="0" rIns="0" tIns="18288" bIns="0"/>
+          <a:lstStyle/>
+          <a:p>
+            <a:pPr algn="ctr">
+              <a:defRPr sz="1000" b="1">
+                <a:solidFill>
+                  <a:srgbClr val="FFFFFF"/>
+                </a:solidFill>
+              </a:defRPr>
+            </a:pPr>
+            <a:r>
+              <a:t>2</a:t>
+            </a:r>
+          </a:p>
+        </p:txBody>
+      </p:sp>
+      <p:sp>
+        <p:nvSpPr>
+          <p:cNvPr id="15" name="TextBox 14"/>
           <p:cNvSpPr txBox="1"/>
           <p:nvPr/>
         </p:nvSpPr>
         <p:spPr>
           <a:xfrm>
-            <a:off x="6537960" y="1664208"/>
-            <a:ext cx="1828800" cy="329184"/>
+            <a:off x="4475988" y="3108960"/>
+            <a:ext cx="1737360" cy="365760"/>
           </a:xfrm>
           <a:prstGeom prst="rect">
             <a:avLst/>
@@ -6663,36 +6909,37 @@
           <a:lstStyle/>
           <a:p>
             <a:pPr algn="ctr">
-              <a:defRPr sz="1000">
-                <a:solidFill>
-                  <a:srgbClr val="555555"/>
-                </a:solidFill>
-              </a:defRPr>
-            </a:pPr>
-            <a:r>
-              <a:t>attacks (HTTP)</a:t>
+              <a:defRPr sz="1100" b="1">
+                <a:solidFill>
+                  <a:srgbClr val="1A2B4C"/>
+                </a:solidFill>
+              </a:defRPr>
+            </a:pPr>
+            <a:r>
+              <a:t>attack (HTTP)</a:t>
             </a:r>
           </a:p>
         </p:txBody>
       </p:sp>
       <p:cxnSp>
         <p:nvCxnSpPr>
-          <p:cNvPr id="13" name="Connector 12"/>
+          <p:cNvPr id="16" name="Connector 15"/>
           <p:cNvCxnSpPr/>
           <p:nvPr/>
         </p:nvCxnSpPr>
         <p:spPr>
-          <a:xfrm flipH="1">
-            <a:off x="4114800" y="2468880"/>
-            <a:ext cx="5897880" cy="1280159"/>
+          <a:xfrm>
+            <a:off x="7735823" y="3063240"/>
+            <a:ext cx="356617" cy="0"/>
           </a:xfrm>
           <a:prstGeom prst="line">
             <a:avLst/>
           </a:prstGeom>
-          <a:ln w="25400">
+          <a:ln w="38100">
             <a:solidFill>
               <a:srgbClr val="1A2B4C"/>
             </a:solidFill>
+            <a:tailEnd type="triangle" w="med" len="med"/>
           </a:ln>
         </p:spPr>
         <p:style>
@@ -6712,14 +6959,66 @@
       </p:cxnSp>
       <p:sp>
         <p:nvSpPr>
-          <p:cNvPr id="14" name="TextBox 13"/>
+          <p:cNvPr id="17" name="Oval 16"/>
+          <p:cNvSpPr/>
+          <p:nvPr/>
+        </p:nvSpPr>
+        <p:spPr>
+          <a:xfrm>
+            <a:off x="7786115" y="2350008"/>
+            <a:ext cx="256032" cy="256032"/>
+          </a:xfrm>
+          <a:prstGeom prst="ellipse">
+            <a:avLst/>
+          </a:prstGeom>
+          <a:solidFill>
+            <a:srgbClr val="1A2B4C"/>
+          </a:solidFill>
+          <a:ln>
+            <a:noFill/>
+          </a:ln>
+        </p:spPr>
+        <p:style>
+          <a:lnRef idx="1">
+            <a:schemeClr val="accent1"/>
+          </a:lnRef>
+          <a:fillRef idx="3">
+            <a:schemeClr val="accent1"/>
+          </a:fillRef>
+          <a:effectRef idx="2">
+            <a:schemeClr val="accent1"/>
+          </a:effectRef>
+          <a:fontRef idx="minor">
+            <a:schemeClr val="lt1"/>
+          </a:fontRef>
+        </p:style>
+        <p:txBody>
+          <a:bodyPr rtlCol="0" anchor="ctr" lIns="0" rIns="0" tIns="18288" bIns="0"/>
+          <a:lstStyle/>
+          <a:p>
+            <a:pPr algn="ctr">
+              <a:defRPr sz="1000" b="1">
+                <a:solidFill>
+                  <a:srgbClr val="FFFFFF"/>
+                </a:solidFill>
+              </a:defRPr>
+            </a:pPr>
+            <a:r>
+              <a:t>3</a:t>
+            </a:r>
+          </a:p>
+        </p:txBody>
+      </p:sp>
+      <p:sp>
+        <p:nvSpPr>
+          <p:cNvPr id="18" name="TextBox 17"/>
           <p:cNvSpPr txBox="1"/>
           <p:nvPr/>
         </p:nvSpPr>
         <p:spPr>
           <a:xfrm>
-            <a:off x="6149340" y="2944368"/>
-            <a:ext cx="1828800" cy="329184"/>
+            <a:off x="7045451" y="3108960"/>
+            <a:ext cx="1737360" cy="365760"/>
           </a:xfrm>
           <a:prstGeom prst="rect">
             <a:avLst/>
@@ -6733,36 +7032,37 @@
           <a:lstStyle/>
           <a:p>
             <a:pPr algn="ctr">
-              <a:defRPr sz="1000">
-                <a:solidFill>
-                  <a:srgbClr val="555555"/>
-                </a:solidFill>
-              </a:defRPr>
-            </a:pPr>
-            <a:r>
-              <a:t>responses</a:t>
+              <a:defRPr sz="1100" b="1">
+                <a:solidFill>
+                  <a:srgbClr val="1A2B4C"/>
+                </a:solidFill>
+              </a:defRPr>
+            </a:pPr>
+            <a:r>
+              <a:t>response</a:t>
             </a:r>
           </a:p>
         </p:txBody>
       </p:sp>
       <p:cxnSp>
         <p:nvCxnSpPr>
-          <p:cNvPr id="15" name="Connector 14"/>
+          <p:cNvPr id="19" name="Connector 18"/>
           <p:cNvCxnSpPr/>
           <p:nvPr/>
         </p:nvCxnSpPr>
         <p:spPr>
           <a:xfrm>
-            <a:off x="4114800" y="5029200"/>
-            <a:ext cx="2286000" cy="0"/>
+            <a:off x="10305287" y="3063240"/>
+            <a:ext cx="356617" cy="0"/>
           </a:xfrm>
           <a:prstGeom prst="line">
             <a:avLst/>
           </a:prstGeom>
-          <a:ln w="25400">
+          <a:ln w="38100">
             <a:solidFill>
               <a:srgbClr val="1A2B4C"/>
             </a:solidFill>
+            <a:tailEnd type="triangle" w="med" len="med"/>
           </a:ln>
         </p:spPr>
         <p:style>
@@ -6782,14 +7082,66 @@
       </p:cxnSp>
       <p:sp>
         <p:nvSpPr>
-          <p:cNvPr id="16" name="TextBox 15"/>
+          <p:cNvPr id="20" name="Oval 19"/>
+          <p:cNvSpPr/>
+          <p:nvPr/>
+        </p:nvSpPr>
+        <p:spPr>
+          <a:xfrm>
+            <a:off x="10355580" y="2350008"/>
+            <a:ext cx="256032" cy="256032"/>
+          </a:xfrm>
+          <a:prstGeom prst="ellipse">
+            <a:avLst/>
+          </a:prstGeom>
+          <a:solidFill>
+            <a:srgbClr val="1A2B4C"/>
+          </a:solidFill>
+          <a:ln>
+            <a:noFill/>
+          </a:ln>
+        </p:spPr>
+        <p:style>
+          <a:lnRef idx="1">
+            <a:schemeClr val="accent1"/>
+          </a:lnRef>
+          <a:fillRef idx="3">
+            <a:schemeClr val="accent1"/>
+          </a:fillRef>
+          <a:effectRef idx="2">
+            <a:schemeClr val="accent1"/>
+          </a:effectRef>
+          <a:fontRef idx="minor">
+            <a:schemeClr val="lt1"/>
+          </a:fontRef>
+        </p:style>
+        <p:txBody>
+          <a:bodyPr rtlCol="0" anchor="ctr" lIns="0" rIns="0" tIns="18288" bIns="0"/>
+          <a:lstStyle/>
+          <a:p>
+            <a:pPr algn="ctr">
+              <a:defRPr sz="1000" b="1">
+                <a:solidFill>
+                  <a:srgbClr val="FFFFFF"/>
+                </a:solidFill>
+              </a:defRPr>
+            </a:pPr>
+            <a:r>
+              <a:t>4</a:t>
+            </a:r>
+          </a:p>
+        </p:txBody>
+      </p:sp>
+      <p:sp>
+        <p:nvSpPr>
+          <p:cNvPr id="21" name="TextBox 20"/>
           <p:cNvSpPr txBox="1"/>
           <p:nvPr/>
         </p:nvSpPr>
         <p:spPr>
           <a:xfrm>
-            <a:off x="4343400" y="4864608"/>
-            <a:ext cx="1828800" cy="329184"/>
+            <a:off x="9614916" y="3108960"/>
+            <a:ext cx="1737360" cy="365760"/>
           </a:xfrm>
           <a:prstGeom prst="rect">
             <a:avLst/>
@@ -6803,36 +7155,37 @@
           <a:lstStyle/>
           <a:p>
             <a:pPr algn="ctr">
-              <a:defRPr sz="1000">
-                <a:solidFill>
-                  <a:srgbClr val="555555"/>
-                </a:solidFill>
-              </a:defRPr>
-            </a:pPr>
-            <a:r>
-              <a:t>confirmed exploits</a:t>
+              <a:defRPr sz="1100" b="1">
+                <a:solidFill>
+                  <a:srgbClr val="1A2B4C"/>
+                </a:solidFill>
+              </a:defRPr>
+            </a:pPr>
+            <a:r>
+              <a:t>confirmed exploit</a:t>
             </a:r>
           </a:p>
         </p:txBody>
       </p:sp>
       <p:cxnSp>
         <p:nvCxnSpPr>
-          <p:cNvPr id="17" name="Connector 16"/>
+          <p:cNvPr id="22" name="Connector 21"/>
           <p:cNvCxnSpPr/>
           <p:nvPr/>
         </p:nvCxnSpPr>
         <p:spPr>
-          <a:xfrm flipH="1" flipV="1">
-            <a:off x="1783080" y="2468880"/>
-            <a:ext cx="1508760" cy="1280159"/>
+          <a:xfrm>
+            <a:off x="9198863" y="3977639"/>
+            <a:ext cx="0" cy="868681"/>
           </a:xfrm>
           <a:prstGeom prst="line">
             <a:avLst/>
           </a:prstGeom>
-          <a:ln w="25400">
+          <a:ln w="38100">
             <a:solidFill>
               <a:srgbClr val="1A2B4C"/>
             </a:solidFill>
+            <a:prstDash val="lgDash"/>
           </a:ln>
         </p:spPr>
         <p:style>
@@ -6850,59 +7203,25 @@
           </a:fontRef>
         </p:style>
       </p:cxnSp>
-      <p:sp>
-        <p:nvSpPr>
-          <p:cNvPr id="18" name="TextBox 17"/>
-          <p:cNvSpPr txBox="1"/>
-          <p:nvPr/>
-        </p:nvSpPr>
-        <p:spPr>
-          <a:xfrm>
-            <a:off x="1623060" y="2944368"/>
-            <a:ext cx="1828800" cy="329184"/>
-          </a:xfrm>
-          <a:prstGeom prst="rect">
-            <a:avLst/>
-          </a:prstGeom>
-          <a:noFill/>
-        </p:spPr>
-        <p:txBody>
-          <a:bodyPr wrap="none">
-            <a:spAutoFit/>
-          </a:bodyPr>
-          <a:lstStyle/>
-          <a:p>
-            <a:pPr algn="ctr">
-              <a:defRPr sz="1000">
-                <a:solidFill>
-                  <a:srgbClr val="555555"/>
-                </a:solidFill>
-              </a:defRPr>
-            </a:pPr>
-            <a:r>
-              <a:t>verdicts → coverage</a:t>
-            </a:r>
-          </a:p>
-        </p:txBody>
-      </p:sp>
       <p:cxnSp>
         <p:nvCxnSpPr>
-          <p:cNvPr id="19" name="Connector 18"/>
+          <p:cNvPr id="23" name="Connector 22"/>
           <p:cNvCxnSpPr/>
           <p:nvPr/>
         </p:nvCxnSpPr>
         <p:spPr>
-          <a:xfrm>
-            <a:off x="6858000" y="5029200"/>
-            <a:ext cx="1371600" cy="1005840"/>
+          <a:xfrm flipH="1">
+            <a:off x="1490472" y="4846320"/>
+            <a:ext cx="7708391" cy="0"/>
           </a:xfrm>
           <a:prstGeom prst="line">
             <a:avLst/>
           </a:prstGeom>
-          <a:ln w="25400">
+          <a:ln w="38100">
             <a:solidFill>
               <a:srgbClr val="1A2B4C"/>
             </a:solidFill>
+            <a:prstDash val="lgDash"/>
           </a:ln>
         </p:spPr>
         <p:style>
@@ -6920,16 +7239,105 @@
           </a:fontRef>
         </p:style>
       </p:cxnSp>
-      <p:sp>
-        <p:nvSpPr>
-          <p:cNvPr id="20" name="TextBox 19"/>
+      <p:cxnSp>
+        <p:nvCxnSpPr>
+          <p:cNvPr id="24" name="Connector 23"/>
+          <p:cNvCxnSpPr/>
+          <p:nvPr/>
+        </p:nvCxnSpPr>
+        <p:spPr>
+          <a:xfrm flipV="1">
+            <a:off x="1490472" y="4005072"/>
+            <a:ext cx="0" cy="841248"/>
+          </a:xfrm>
+          <a:prstGeom prst="line">
+            <a:avLst/>
+          </a:prstGeom>
+          <a:ln w="38100">
+            <a:solidFill>
+              <a:srgbClr val="1A2B4C"/>
+            </a:solidFill>
+            <a:prstDash val="lgDash"/>
+            <a:tailEnd type="triangle" w="med" len="med"/>
+          </a:ln>
+        </p:spPr>
+        <p:style>
+          <a:lnRef idx="2">
+            <a:schemeClr val="accent1"/>
+          </a:lnRef>
+          <a:fillRef idx="0">
+            <a:schemeClr val="accent1"/>
+          </a:fillRef>
+          <a:effectRef idx="1">
+            <a:schemeClr val="accent1"/>
+          </a:effectRef>
+          <a:fontRef idx="minor">
+            <a:schemeClr val="tx1"/>
+          </a:fontRef>
+        </p:style>
+      </p:cxnSp>
+      <p:sp>
+        <p:nvSpPr>
+          <p:cNvPr id="25" name="Oval 24"/>
+          <p:cNvSpPr/>
+          <p:nvPr/>
+        </p:nvSpPr>
+        <p:spPr>
+          <a:xfrm>
+            <a:off x="5216651" y="4718304"/>
+            <a:ext cx="256032" cy="256032"/>
+          </a:xfrm>
+          <a:prstGeom prst="ellipse">
+            <a:avLst/>
+          </a:prstGeom>
+          <a:solidFill>
+            <a:srgbClr val="1A2B4C"/>
+          </a:solidFill>
+          <a:ln>
+            <a:noFill/>
+          </a:ln>
+        </p:spPr>
+        <p:style>
+          <a:lnRef idx="1">
+            <a:schemeClr val="accent1"/>
+          </a:lnRef>
+          <a:fillRef idx="3">
+            <a:schemeClr val="accent1"/>
+          </a:fillRef>
+          <a:effectRef idx="2">
+            <a:schemeClr val="accent1"/>
+          </a:effectRef>
+          <a:fontRef idx="minor">
+            <a:schemeClr val="lt1"/>
+          </a:fontRef>
+        </p:style>
+        <p:txBody>
+          <a:bodyPr rtlCol="0" anchor="ctr" lIns="0" rIns="0" tIns="18288" bIns="0"/>
+          <a:lstStyle/>
+          <a:p>
+            <a:pPr algn="ctr">
+              <a:defRPr sz="1000" b="1">
+                <a:solidFill>
+                  <a:srgbClr val="FFFFFF"/>
+                </a:solidFill>
+              </a:defRPr>
+            </a:pPr>
+            <a:r>
+              <a:t>5</a:t>
+            </a:r>
+          </a:p>
+        </p:txBody>
+      </p:sp>
+      <p:sp>
+        <p:nvSpPr>
+          <p:cNvPr id="26" name="TextBox 25"/>
           <p:cNvSpPr txBox="1"/>
           <p:nvPr/>
         </p:nvSpPr>
         <p:spPr>
           <a:xfrm>
-            <a:off x="6629400" y="5367528"/>
-            <a:ext cx="1828800" cy="329184"/>
+            <a:off x="3332987" y="4937759"/>
+            <a:ext cx="4023360" cy="365760"/>
           </a:xfrm>
           <a:prstGeom prst="rect">
             <a:avLst/>
@@ -6943,49 +7351,68 @@
           <a:lstStyle/>
           <a:p>
             <a:pPr algn="ctr">
-              <a:defRPr sz="1000">
-                <a:solidFill>
-                  <a:srgbClr val="555555"/>
-                </a:solidFill>
-              </a:defRPr>
-            </a:pPr>
-            <a:r>
-              <a:t>VULN-NNNN.md</a:t>
-            </a:r>
-          </a:p>
-        </p:txBody>
-      </p:sp>
-      <p:sp>
-        <p:nvSpPr>
-          <p:cNvPr id="21" name="TextBox 20"/>
-          <p:cNvSpPr txBox="1"/>
+              <a:defRPr sz="1200" b="1">
+                <a:solidFill>
+                  <a:srgbClr val="1A2B4C"/>
+                </a:solidFill>
+              </a:defRPr>
+            </a:pPr>
+            <a:r>
+              <a:t>verdicts + coverage feedback → next campaign</a:t>
+            </a:r>
+          </a:p>
+        </p:txBody>
+      </p:sp>
+      <p:sp>
+        <p:nvSpPr>
+          <p:cNvPr id="27" name="Rectangle 26"/>
+          <p:cNvSpPr/>
           <p:nvPr/>
         </p:nvSpPr>
         <p:spPr>
           <a:xfrm>
-            <a:off x="457200" y="6309360"/>
-            <a:ext cx="11247120" cy="365760"/>
+            <a:off x="365760" y="6263640"/>
+            <a:ext cx="11475720" cy="365760"/>
           </a:xfrm>
           <a:prstGeom prst="rect">
             <a:avLst/>
           </a:prstGeom>
-          <a:noFill/>
-        </p:spPr>
-        <p:txBody>
-          <a:bodyPr wrap="none">
-            <a:spAutoFit/>
-          </a:bodyPr>
-          <a:lstStyle/>
-          <a:p>
-            <a:pPr>
+          <a:solidFill>
+            <a:srgbClr val="F1F1F4"/>
+          </a:solidFill>
+          <a:ln w="6350">
+            <a:solidFill>
+              <a:srgbClr val="D0D0D0"/>
+            </a:solidFill>
+          </a:ln>
+        </p:spPr>
+        <p:style>
+          <a:lnRef idx="1">
+            <a:schemeClr val="accent1"/>
+          </a:lnRef>
+          <a:fillRef idx="3">
+            <a:schemeClr val="accent1"/>
+          </a:fillRef>
+          <a:effectRef idx="2">
+            <a:schemeClr val="accent1"/>
+          </a:effectRef>
+          <a:fontRef idx="minor">
+            <a:schemeClr val="lt1"/>
+          </a:fontRef>
+        </p:style>
+        <p:txBody>
+          <a:bodyPr rtlCol="0" anchor="ctr" lIns="109728" tIns="54864" bIns="54864"/>
+          <a:lstStyle/>
+          <a:p>
+            <a:pPr algn="ctr">
               <a:defRPr sz="1100">
                 <a:solidFill>
-                  <a:srgbClr val="555555"/>
-                </a:solidFill>
-              </a:defRPr>
-            </a:pPr>
-            <a:r>
-              <a:t>Postgres carries inter-agent state · Langfuse tags every span by agent_role · target-host allowlist enforced in harness/executor.py</a:t>
+                  <a:srgbClr val="1A2B4C"/>
+                </a:solidFill>
+              </a:defRPr>
+            </a:pPr>
+            <a:r>
+              <a:t>Substrate: Postgres  ·  Langfuse spans tagged by agent_role  ·  harness/executor.py enforces target-host allowlist on every HTTP call</a:t>
             </a:r>
           </a:p>
         </p:txBody>

</xml_diff>

<commit_message>
Fix slide 5 box-width overflow + Coverage Figma mock
Deck: shrink box width from 2.36" to 2.30" and gutter from 0.45" to 0.30"
so all five boxes (Orchestrator/Red Team/Target/Judge/Documentation)
fit within the 13.33" slide width (last edge at 13.02", symmetric 0.31"
margins). Replace the cluttered overlapping arrow labels with a clean
legend strip below the boxes — numbered badges on the arrows, decoded
in the strip ("1: campaign brief", "2: attack (HTTP)", etc.).
Feedback arrow 5 moved below the legend so nothing overlaps.

Mocks: 04_coverage.png — full 17-row ranked coverage matrix with sev,
priority, case count, pass-rate mini-bars, exploit counts, last-run
time. Sourced from THREAT_MODEL.md priority table.
</commit_message>
<xml_diff>
--- a/ARCHITECTURE_DEFENSE.pptx
+++ b/ARCHITECTURE_DEFENSE.pptx
@@ -6180,8 +6180,8 @@
         </p:nvSpPr>
         <p:spPr>
           <a:xfrm>
-            <a:off x="411480" y="2148840"/>
-            <a:ext cx="2157984" cy="1828800"/>
+            <a:off x="288036" y="2148840"/>
+            <a:ext cx="2103120" cy="1828800"/>
           </a:xfrm>
           <a:prstGeom prst="roundRect">
             <a:avLst/>
@@ -6279,8 +6279,8 @@
         </p:nvSpPr>
         <p:spPr>
           <a:xfrm>
-            <a:off x="2980944" y="2148840"/>
-            <a:ext cx="2157984" cy="1828800"/>
+            <a:off x="2665475" y="2148840"/>
+            <a:ext cx="2103120" cy="1828800"/>
           </a:xfrm>
           <a:prstGeom prst="roundRect">
             <a:avLst/>
@@ -6382,8 +6382,8 @@
         </p:nvSpPr>
         <p:spPr>
           <a:xfrm>
-            <a:off x="5550408" y="2148840"/>
-            <a:ext cx="2157984" cy="1828800"/>
+            <a:off x="5042916" y="2148840"/>
+            <a:ext cx="2103120" cy="1828800"/>
           </a:xfrm>
           <a:prstGeom prst="roundRect">
             <a:avLst/>
@@ -6485,8 +6485,8 @@
         </p:nvSpPr>
         <p:spPr>
           <a:xfrm>
-            <a:off x="8119871" y="2148840"/>
-            <a:ext cx="2157984" cy="1828800"/>
+            <a:off x="7420355" y="2148840"/>
+            <a:ext cx="2103120" cy="1828800"/>
           </a:xfrm>
           <a:prstGeom prst="roundRect">
             <a:avLst/>
@@ -6584,8 +6584,8 @@
         </p:nvSpPr>
         <p:spPr>
           <a:xfrm>
-            <a:off x="10689336" y="2148840"/>
-            <a:ext cx="2157984" cy="1828800"/>
+            <a:off x="9797795" y="2148840"/>
+            <a:ext cx="2103120" cy="1828800"/>
           </a:xfrm>
           <a:prstGeom prst="roundRect">
             <a:avLst/>
@@ -6683,8 +6683,8 @@
         </p:nvCxnSpPr>
         <p:spPr>
           <a:xfrm>
-            <a:off x="2596896" y="3063240"/>
-            <a:ext cx="356616" cy="0"/>
+            <a:off x="2418587" y="3063240"/>
+            <a:ext cx="219457" cy="0"/>
           </a:xfrm>
           <a:prstGeom prst="line">
             <a:avLst/>
@@ -6719,8 +6719,332 @@
         </p:nvSpPr>
         <p:spPr>
           <a:xfrm>
-            <a:off x="2647188" y="2350008"/>
-            <a:ext cx="256032" cy="256032"/>
+            <a:off x="2391156" y="2926080"/>
+            <a:ext cx="274320" cy="274320"/>
+          </a:xfrm>
+          <a:prstGeom prst="ellipse">
+            <a:avLst/>
+          </a:prstGeom>
+          <a:solidFill>
+            <a:srgbClr val="1A2B4C"/>
+          </a:solidFill>
+          <a:ln w="19050">
+            <a:solidFill>
+              <a:srgbClr val="FFFFFF"/>
+            </a:solidFill>
+          </a:ln>
+        </p:spPr>
+        <p:style>
+          <a:lnRef idx="1">
+            <a:schemeClr val="accent1"/>
+          </a:lnRef>
+          <a:fillRef idx="3">
+            <a:schemeClr val="accent1"/>
+          </a:fillRef>
+          <a:effectRef idx="2">
+            <a:schemeClr val="accent1"/>
+          </a:effectRef>
+          <a:fontRef idx="minor">
+            <a:schemeClr val="lt1"/>
+          </a:fontRef>
+        </p:style>
+        <p:txBody>
+          <a:bodyPr rtlCol="0" anchor="ctr" lIns="0" rIns="0" tIns="27432" bIns="0"/>
+          <a:lstStyle/>
+          <a:p>
+            <a:pPr algn="ctr">
+              <a:defRPr sz="1100" b="1">
+                <a:solidFill>
+                  <a:srgbClr val="FFFFFF"/>
+                </a:solidFill>
+              </a:defRPr>
+            </a:pPr>
+            <a:r>
+              <a:t>1</a:t>
+            </a:r>
+          </a:p>
+        </p:txBody>
+      </p:sp>
+      <p:cxnSp>
+        <p:nvCxnSpPr>
+          <p:cNvPr id="12" name="Connector 11"/>
+          <p:cNvCxnSpPr/>
+          <p:nvPr/>
+        </p:nvCxnSpPr>
+        <p:spPr>
+          <a:xfrm>
+            <a:off x="4796028" y="3063240"/>
+            <a:ext cx="219455" cy="0"/>
+          </a:xfrm>
+          <a:prstGeom prst="line">
+            <a:avLst/>
+          </a:prstGeom>
+          <a:ln w="38100">
+            <a:solidFill>
+              <a:srgbClr val="1A2B4C"/>
+            </a:solidFill>
+            <a:tailEnd type="triangle" w="med" len="med"/>
+          </a:ln>
+        </p:spPr>
+        <p:style>
+          <a:lnRef idx="2">
+            <a:schemeClr val="accent1"/>
+          </a:lnRef>
+          <a:fillRef idx="0">
+            <a:schemeClr val="accent1"/>
+          </a:fillRef>
+          <a:effectRef idx="1">
+            <a:schemeClr val="accent1"/>
+          </a:effectRef>
+          <a:fontRef idx="minor">
+            <a:schemeClr val="tx1"/>
+          </a:fontRef>
+        </p:style>
+      </p:cxnSp>
+      <p:sp>
+        <p:nvSpPr>
+          <p:cNvPr id="13" name="Oval 12"/>
+          <p:cNvSpPr/>
+          <p:nvPr/>
+        </p:nvSpPr>
+        <p:spPr>
+          <a:xfrm>
+            <a:off x="4768596" y="2926080"/>
+            <a:ext cx="274320" cy="274320"/>
+          </a:xfrm>
+          <a:prstGeom prst="ellipse">
+            <a:avLst/>
+          </a:prstGeom>
+          <a:solidFill>
+            <a:srgbClr val="1A2B4C"/>
+          </a:solidFill>
+          <a:ln w="19050">
+            <a:solidFill>
+              <a:srgbClr val="FFFFFF"/>
+            </a:solidFill>
+          </a:ln>
+        </p:spPr>
+        <p:style>
+          <a:lnRef idx="1">
+            <a:schemeClr val="accent1"/>
+          </a:lnRef>
+          <a:fillRef idx="3">
+            <a:schemeClr val="accent1"/>
+          </a:fillRef>
+          <a:effectRef idx="2">
+            <a:schemeClr val="accent1"/>
+          </a:effectRef>
+          <a:fontRef idx="minor">
+            <a:schemeClr val="lt1"/>
+          </a:fontRef>
+        </p:style>
+        <p:txBody>
+          <a:bodyPr rtlCol="0" anchor="ctr" lIns="0" rIns="0" tIns="27432" bIns="0"/>
+          <a:lstStyle/>
+          <a:p>
+            <a:pPr algn="ctr">
+              <a:defRPr sz="1100" b="1">
+                <a:solidFill>
+                  <a:srgbClr val="FFFFFF"/>
+                </a:solidFill>
+              </a:defRPr>
+            </a:pPr>
+            <a:r>
+              <a:t>2</a:t>
+            </a:r>
+          </a:p>
+        </p:txBody>
+      </p:sp>
+      <p:cxnSp>
+        <p:nvCxnSpPr>
+          <p:cNvPr id="14" name="Connector 13"/>
+          <p:cNvCxnSpPr/>
+          <p:nvPr/>
+        </p:nvCxnSpPr>
+        <p:spPr>
+          <a:xfrm>
+            <a:off x="7173468" y="3063240"/>
+            <a:ext cx="219455" cy="0"/>
+          </a:xfrm>
+          <a:prstGeom prst="line">
+            <a:avLst/>
+          </a:prstGeom>
+          <a:ln w="38100">
+            <a:solidFill>
+              <a:srgbClr val="1A2B4C"/>
+            </a:solidFill>
+            <a:tailEnd type="triangle" w="med" len="med"/>
+          </a:ln>
+        </p:spPr>
+        <p:style>
+          <a:lnRef idx="2">
+            <a:schemeClr val="accent1"/>
+          </a:lnRef>
+          <a:fillRef idx="0">
+            <a:schemeClr val="accent1"/>
+          </a:fillRef>
+          <a:effectRef idx="1">
+            <a:schemeClr val="accent1"/>
+          </a:effectRef>
+          <a:fontRef idx="minor">
+            <a:schemeClr val="tx1"/>
+          </a:fontRef>
+        </p:style>
+      </p:cxnSp>
+      <p:sp>
+        <p:nvSpPr>
+          <p:cNvPr id="15" name="Oval 14"/>
+          <p:cNvSpPr/>
+          <p:nvPr/>
+        </p:nvSpPr>
+        <p:spPr>
+          <a:xfrm>
+            <a:off x="7146036" y="2926080"/>
+            <a:ext cx="274320" cy="274320"/>
+          </a:xfrm>
+          <a:prstGeom prst="ellipse">
+            <a:avLst/>
+          </a:prstGeom>
+          <a:solidFill>
+            <a:srgbClr val="1A2B4C"/>
+          </a:solidFill>
+          <a:ln w="19050">
+            <a:solidFill>
+              <a:srgbClr val="FFFFFF"/>
+            </a:solidFill>
+          </a:ln>
+        </p:spPr>
+        <p:style>
+          <a:lnRef idx="1">
+            <a:schemeClr val="accent1"/>
+          </a:lnRef>
+          <a:fillRef idx="3">
+            <a:schemeClr val="accent1"/>
+          </a:fillRef>
+          <a:effectRef idx="2">
+            <a:schemeClr val="accent1"/>
+          </a:effectRef>
+          <a:fontRef idx="minor">
+            <a:schemeClr val="lt1"/>
+          </a:fontRef>
+        </p:style>
+        <p:txBody>
+          <a:bodyPr rtlCol="0" anchor="ctr" lIns="0" rIns="0" tIns="27432" bIns="0"/>
+          <a:lstStyle/>
+          <a:p>
+            <a:pPr algn="ctr">
+              <a:defRPr sz="1100" b="1">
+                <a:solidFill>
+                  <a:srgbClr val="FFFFFF"/>
+                </a:solidFill>
+              </a:defRPr>
+            </a:pPr>
+            <a:r>
+              <a:t>3</a:t>
+            </a:r>
+          </a:p>
+        </p:txBody>
+      </p:sp>
+      <p:cxnSp>
+        <p:nvCxnSpPr>
+          <p:cNvPr id="16" name="Connector 15"/>
+          <p:cNvCxnSpPr/>
+          <p:nvPr/>
+        </p:nvCxnSpPr>
+        <p:spPr>
+          <a:xfrm>
+            <a:off x="9550907" y="3063240"/>
+            <a:ext cx="219456" cy="0"/>
+          </a:xfrm>
+          <a:prstGeom prst="line">
+            <a:avLst/>
+          </a:prstGeom>
+          <a:ln w="38100">
+            <a:solidFill>
+              <a:srgbClr val="1A2B4C"/>
+            </a:solidFill>
+            <a:tailEnd type="triangle" w="med" len="med"/>
+          </a:ln>
+        </p:spPr>
+        <p:style>
+          <a:lnRef idx="2">
+            <a:schemeClr val="accent1"/>
+          </a:lnRef>
+          <a:fillRef idx="0">
+            <a:schemeClr val="accent1"/>
+          </a:fillRef>
+          <a:effectRef idx="1">
+            <a:schemeClr val="accent1"/>
+          </a:effectRef>
+          <a:fontRef idx="minor">
+            <a:schemeClr val="tx1"/>
+          </a:fontRef>
+        </p:style>
+      </p:cxnSp>
+      <p:sp>
+        <p:nvSpPr>
+          <p:cNvPr id="17" name="Oval 16"/>
+          <p:cNvSpPr/>
+          <p:nvPr/>
+        </p:nvSpPr>
+        <p:spPr>
+          <a:xfrm>
+            <a:off x="9523475" y="2926080"/>
+            <a:ext cx="274320" cy="274320"/>
+          </a:xfrm>
+          <a:prstGeom prst="ellipse">
+            <a:avLst/>
+          </a:prstGeom>
+          <a:solidFill>
+            <a:srgbClr val="1A2B4C"/>
+          </a:solidFill>
+          <a:ln w="19050">
+            <a:solidFill>
+              <a:srgbClr val="FFFFFF"/>
+            </a:solidFill>
+          </a:ln>
+        </p:spPr>
+        <p:style>
+          <a:lnRef idx="1">
+            <a:schemeClr val="accent1"/>
+          </a:lnRef>
+          <a:fillRef idx="3">
+            <a:schemeClr val="accent1"/>
+          </a:fillRef>
+          <a:effectRef idx="2">
+            <a:schemeClr val="accent1"/>
+          </a:effectRef>
+          <a:fontRef idx="minor">
+            <a:schemeClr val="lt1"/>
+          </a:fontRef>
+        </p:style>
+        <p:txBody>
+          <a:bodyPr rtlCol="0" anchor="ctr" lIns="0" rIns="0" tIns="27432" bIns="0"/>
+          <a:lstStyle/>
+          <a:p>
+            <a:pPr algn="ctr">
+              <a:defRPr sz="1100" b="1">
+                <a:solidFill>
+                  <a:srgbClr val="FFFFFF"/>
+                </a:solidFill>
+              </a:defRPr>
+            </a:pPr>
+            <a:r>
+              <a:t>4</a:t>
+            </a:r>
+          </a:p>
+        </p:txBody>
+      </p:sp>
+      <p:sp>
+        <p:nvSpPr>
+          <p:cNvPr id="18" name="Oval 17"/>
+          <p:cNvSpPr/>
+          <p:nvPr/>
+        </p:nvSpPr>
+        <p:spPr>
+          <a:xfrm>
+            <a:off x="1529334" y="4197096"/>
+            <a:ext cx="201168" cy="201168"/>
           </a:xfrm>
           <a:prstGeom prst="ellipse">
             <a:avLst/>
@@ -6751,7 +7075,7 @@
           <a:lstStyle/>
           <a:p>
             <a:pPr algn="ctr">
-              <a:defRPr sz="1000" b="1">
+              <a:defRPr sz="900" b="1">
                 <a:solidFill>
                   <a:srgbClr val="FFFFFF"/>
                 </a:solidFill>
@@ -6765,14 +7089,14 @@
       </p:sp>
       <p:sp>
         <p:nvSpPr>
-          <p:cNvPr id="12" name="TextBox 11"/>
+          <p:cNvPr id="19" name="TextBox 18"/>
           <p:cNvSpPr txBox="1"/>
           <p:nvPr/>
         </p:nvSpPr>
         <p:spPr>
           <a:xfrm>
-            <a:off x="1906524" y="3108960"/>
-            <a:ext cx="1737360" cy="365760"/>
+            <a:off x="1785366" y="4160520"/>
+            <a:ext cx="1741931" cy="292608"/>
           </a:xfrm>
           <a:prstGeom prst="rect">
             <a:avLst/>
@@ -6785,8 +7109,8 @@
           </a:bodyPr>
           <a:lstStyle/>
           <a:p>
-            <a:pPr algn="ctr">
-              <a:defRPr sz="1100" b="1">
+            <a:pPr algn="l">
+              <a:defRPr sz="1200" b="1">
                 <a:solidFill>
                   <a:srgbClr val="1A2B4C"/>
                 </a:solidFill>
@@ -6798,52 +7122,16 @@
           </a:p>
         </p:txBody>
       </p:sp>
-      <p:cxnSp>
-        <p:nvCxnSpPr>
-          <p:cNvPr id="13" name="Connector 12"/>
-          <p:cNvCxnSpPr/>
-          <p:nvPr/>
-        </p:nvCxnSpPr>
-        <p:spPr>
-          <a:xfrm>
-            <a:off x="5166360" y="3063240"/>
-            <a:ext cx="356616" cy="0"/>
-          </a:xfrm>
-          <a:prstGeom prst="line">
-            <a:avLst/>
-          </a:prstGeom>
-          <a:ln w="38100">
-            <a:solidFill>
-              <a:srgbClr val="1A2B4C"/>
-            </a:solidFill>
-            <a:tailEnd type="triangle" w="med" len="med"/>
-          </a:ln>
-        </p:spPr>
-        <p:style>
-          <a:lnRef idx="2">
-            <a:schemeClr val="accent1"/>
-          </a:lnRef>
-          <a:fillRef idx="0">
-            <a:schemeClr val="accent1"/>
-          </a:fillRef>
-          <a:effectRef idx="1">
-            <a:schemeClr val="accent1"/>
-          </a:effectRef>
-          <a:fontRef idx="minor">
-            <a:schemeClr val="tx1"/>
-          </a:fontRef>
-        </p:style>
-      </p:cxnSp>
-      <p:sp>
-        <p:nvSpPr>
-          <p:cNvPr id="14" name="Oval 13"/>
+      <p:sp>
+        <p:nvSpPr>
+          <p:cNvPr id="20" name="Oval 19"/>
           <p:cNvSpPr/>
           <p:nvPr/>
         </p:nvSpPr>
         <p:spPr>
           <a:xfrm>
-            <a:off x="5216652" y="2350008"/>
-            <a:ext cx="256032" cy="256032"/>
+            <a:off x="3906774" y="4197096"/>
+            <a:ext cx="201168" cy="201168"/>
           </a:xfrm>
           <a:prstGeom prst="ellipse">
             <a:avLst/>
@@ -6874,7 +7162,7 @@
           <a:lstStyle/>
           <a:p>
             <a:pPr algn="ctr">
-              <a:defRPr sz="1000" b="1">
+              <a:defRPr sz="900" b="1">
                 <a:solidFill>
                   <a:srgbClr val="FFFFFF"/>
                 </a:solidFill>
@@ -6888,14 +7176,14 @@
       </p:sp>
       <p:sp>
         <p:nvSpPr>
-          <p:cNvPr id="15" name="TextBox 14"/>
+          <p:cNvPr id="21" name="TextBox 20"/>
           <p:cNvSpPr txBox="1"/>
           <p:nvPr/>
         </p:nvSpPr>
         <p:spPr>
           <a:xfrm>
-            <a:off x="4475988" y="3108960"/>
-            <a:ext cx="1737360" cy="365760"/>
+            <a:off x="4162806" y="4160520"/>
+            <a:ext cx="1741931" cy="292608"/>
           </a:xfrm>
           <a:prstGeom prst="rect">
             <a:avLst/>
@@ -6908,8 +7196,8 @@
           </a:bodyPr>
           <a:lstStyle/>
           <a:p>
-            <a:pPr algn="ctr">
-              <a:defRPr sz="1100" b="1">
+            <a:pPr algn="l">
+              <a:defRPr sz="1200" b="1">
                 <a:solidFill>
                   <a:srgbClr val="1A2B4C"/>
                 </a:solidFill>
@@ -6921,52 +7209,16 @@
           </a:p>
         </p:txBody>
       </p:sp>
-      <p:cxnSp>
-        <p:nvCxnSpPr>
-          <p:cNvPr id="16" name="Connector 15"/>
-          <p:cNvCxnSpPr/>
-          <p:nvPr/>
-        </p:nvCxnSpPr>
-        <p:spPr>
-          <a:xfrm>
-            <a:off x="7735823" y="3063240"/>
-            <a:ext cx="356617" cy="0"/>
-          </a:xfrm>
-          <a:prstGeom prst="line">
-            <a:avLst/>
-          </a:prstGeom>
-          <a:ln w="38100">
-            <a:solidFill>
-              <a:srgbClr val="1A2B4C"/>
-            </a:solidFill>
-            <a:tailEnd type="triangle" w="med" len="med"/>
-          </a:ln>
-        </p:spPr>
-        <p:style>
-          <a:lnRef idx="2">
-            <a:schemeClr val="accent1"/>
-          </a:lnRef>
-          <a:fillRef idx="0">
-            <a:schemeClr val="accent1"/>
-          </a:fillRef>
-          <a:effectRef idx="1">
-            <a:schemeClr val="accent1"/>
-          </a:effectRef>
-          <a:fontRef idx="minor">
-            <a:schemeClr val="tx1"/>
-          </a:fontRef>
-        </p:style>
-      </p:cxnSp>
-      <p:sp>
-        <p:nvSpPr>
-          <p:cNvPr id="17" name="Oval 16"/>
+      <p:sp>
+        <p:nvSpPr>
+          <p:cNvPr id="22" name="Oval 21"/>
           <p:cNvSpPr/>
           <p:nvPr/>
         </p:nvSpPr>
         <p:spPr>
           <a:xfrm>
-            <a:off x="7786115" y="2350008"/>
-            <a:ext cx="256032" cy="256032"/>
+            <a:off x="6284213" y="4197096"/>
+            <a:ext cx="201168" cy="201168"/>
           </a:xfrm>
           <a:prstGeom prst="ellipse">
             <a:avLst/>
@@ -6997,7 +7249,7 @@
           <a:lstStyle/>
           <a:p>
             <a:pPr algn="ctr">
-              <a:defRPr sz="1000" b="1">
+              <a:defRPr sz="900" b="1">
                 <a:solidFill>
                   <a:srgbClr val="FFFFFF"/>
                 </a:solidFill>
@@ -7011,14 +7263,14 @@
       </p:sp>
       <p:sp>
         <p:nvSpPr>
-          <p:cNvPr id="18" name="TextBox 17"/>
+          <p:cNvPr id="23" name="TextBox 22"/>
           <p:cNvSpPr txBox="1"/>
           <p:nvPr/>
         </p:nvSpPr>
         <p:spPr>
           <a:xfrm>
-            <a:off x="7045451" y="3108960"/>
-            <a:ext cx="1737360" cy="365760"/>
+            <a:off x="6540245" y="4160520"/>
+            <a:ext cx="1741931" cy="292608"/>
           </a:xfrm>
           <a:prstGeom prst="rect">
             <a:avLst/>
@@ -7031,8 +7283,8 @@
           </a:bodyPr>
           <a:lstStyle/>
           <a:p>
-            <a:pPr algn="ctr">
-              <a:defRPr sz="1100" b="1">
+            <a:pPr algn="l">
+              <a:defRPr sz="1200" b="1">
                 <a:solidFill>
                   <a:srgbClr val="1A2B4C"/>
                 </a:solidFill>
@@ -7044,52 +7296,16 @@
           </a:p>
         </p:txBody>
       </p:sp>
-      <p:cxnSp>
-        <p:nvCxnSpPr>
-          <p:cNvPr id="19" name="Connector 18"/>
-          <p:cNvCxnSpPr/>
-          <p:nvPr/>
-        </p:nvCxnSpPr>
-        <p:spPr>
-          <a:xfrm>
-            <a:off x="10305287" y="3063240"/>
-            <a:ext cx="356617" cy="0"/>
-          </a:xfrm>
-          <a:prstGeom prst="line">
-            <a:avLst/>
-          </a:prstGeom>
-          <a:ln w="38100">
-            <a:solidFill>
-              <a:srgbClr val="1A2B4C"/>
-            </a:solidFill>
-            <a:tailEnd type="triangle" w="med" len="med"/>
-          </a:ln>
-        </p:spPr>
-        <p:style>
-          <a:lnRef idx="2">
-            <a:schemeClr val="accent1"/>
-          </a:lnRef>
-          <a:fillRef idx="0">
-            <a:schemeClr val="accent1"/>
-          </a:fillRef>
-          <a:effectRef idx="1">
-            <a:schemeClr val="accent1"/>
-          </a:effectRef>
-          <a:fontRef idx="minor">
-            <a:schemeClr val="tx1"/>
-          </a:fontRef>
-        </p:style>
-      </p:cxnSp>
-      <p:sp>
-        <p:nvSpPr>
-          <p:cNvPr id="20" name="Oval 19"/>
+      <p:sp>
+        <p:nvSpPr>
+          <p:cNvPr id="24" name="Oval 23"/>
           <p:cNvSpPr/>
           <p:nvPr/>
         </p:nvSpPr>
         <p:spPr>
           <a:xfrm>
-            <a:off x="10355580" y="2350008"/>
-            <a:ext cx="256032" cy="256032"/>
+            <a:off x="8661653" y="4197096"/>
+            <a:ext cx="201168" cy="201168"/>
           </a:xfrm>
           <a:prstGeom prst="ellipse">
             <a:avLst/>
@@ -7120,7 +7336,7 @@
           <a:lstStyle/>
           <a:p>
             <a:pPr algn="ctr">
-              <a:defRPr sz="1000" b="1">
+              <a:defRPr sz="900" b="1">
                 <a:solidFill>
                   <a:srgbClr val="FFFFFF"/>
                 </a:solidFill>
@@ -7134,14 +7350,14 @@
       </p:sp>
       <p:sp>
         <p:nvSpPr>
-          <p:cNvPr id="21" name="TextBox 20"/>
+          <p:cNvPr id="25" name="TextBox 24"/>
           <p:cNvSpPr txBox="1"/>
           <p:nvPr/>
         </p:nvSpPr>
         <p:spPr>
           <a:xfrm>
-            <a:off x="9614916" y="3108960"/>
-            <a:ext cx="1737360" cy="365760"/>
+            <a:off x="8917686" y="4160520"/>
+            <a:ext cx="1741931" cy="292608"/>
           </a:xfrm>
           <a:prstGeom prst="rect">
             <a:avLst/>
@@ -7154,8 +7370,8 @@
           </a:bodyPr>
           <a:lstStyle/>
           <a:p>
-            <a:pPr algn="ctr">
-              <a:defRPr sz="1100" b="1">
+            <a:pPr algn="l">
+              <a:defRPr sz="1200" b="1">
                 <a:solidFill>
                   <a:srgbClr val="1A2B4C"/>
                 </a:solidFill>
@@ -7169,14 +7385,14 @@
       </p:sp>
       <p:cxnSp>
         <p:nvCxnSpPr>
-          <p:cNvPr id="22" name="Connector 21"/>
+          <p:cNvPr id="26" name="Connector 25"/>
           <p:cNvCxnSpPr/>
           <p:nvPr/>
         </p:nvCxnSpPr>
         <p:spPr>
           <a:xfrm>
-            <a:off x="9198863" y="3977639"/>
-            <a:ext cx="0" cy="868681"/>
+            <a:off x="8471915" y="3977639"/>
+            <a:ext cx="0" cy="960120"/>
           </a:xfrm>
           <a:prstGeom prst="line">
             <a:avLst/>
@@ -7205,14 +7421,14 @@
       </p:cxnSp>
       <p:cxnSp>
         <p:nvCxnSpPr>
-          <p:cNvPr id="23" name="Connector 22"/>
+          <p:cNvPr id="27" name="Connector 26"/>
           <p:cNvCxnSpPr/>
           <p:nvPr/>
         </p:nvCxnSpPr>
         <p:spPr>
           <a:xfrm flipH="1">
-            <a:off x="1490472" y="4846320"/>
-            <a:ext cx="7708391" cy="0"/>
+            <a:off x="1339595" y="4937759"/>
+            <a:ext cx="7132320" cy="0"/>
           </a:xfrm>
           <a:prstGeom prst="line">
             <a:avLst/>
@@ -7241,14 +7457,14 @@
       </p:cxnSp>
       <p:cxnSp>
         <p:nvCxnSpPr>
-          <p:cNvPr id="24" name="Connector 23"/>
+          <p:cNvPr id="28" name="Connector 27"/>
           <p:cNvCxnSpPr/>
           <p:nvPr/>
         </p:nvCxnSpPr>
         <p:spPr>
           <a:xfrm flipV="1">
-            <a:off x="1490472" y="4005072"/>
-            <a:ext cx="0" cy="841248"/>
+            <a:off x="1339595" y="4005072"/>
+            <a:ext cx="0" cy="932687"/>
           </a:xfrm>
           <a:prstGeom prst="line">
             <a:avLst/>
@@ -7278,13 +7494,13 @@
       </p:cxnSp>
       <p:sp>
         <p:nvSpPr>
-          <p:cNvPr id="25" name="Oval 24"/>
+          <p:cNvPr id="29" name="Oval 28"/>
           <p:cNvSpPr/>
           <p:nvPr/>
         </p:nvSpPr>
         <p:spPr>
           <a:xfrm>
-            <a:off x="5216651" y="4718304"/>
+            <a:off x="4777740" y="4809744"/>
             <a:ext cx="256032" cy="256032"/>
           </a:xfrm>
           <a:prstGeom prst="ellipse">
@@ -7330,13 +7546,13 @@
       </p:sp>
       <p:sp>
         <p:nvSpPr>
-          <p:cNvPr id="26" name="TextBox 25"/>
+          <p:cNvPr id="30" name="TextBox 29"/>
           <p:cNvSpPr txBox="1"/>
           <p:nvPr/>
         </p:nvSpPr>
         <p:spPr>
           <a:xfrm>
-            <a:off x="3332987" y="4937759"/>
+            <a:off x="2894075" y="5029199"/>
             <a:ext cx="4023360" cy="365760"/>
           </a:xfrm>
           <a:prstGeom prst="rect">
@@ -7365,7 +7581,7 @@
       </p:sp>
       <p:sp>
         <p:nvSpPr>
-          <p:cNvPr id="27" name="Rectangle 26"/>
+          <p:cNvPr id="31" name="Rectangle 30"/>
           <p:cNvSpPr/>
           <p:nvPr/>
         </p:nvSpPr>

</xml_diff>

<commit_message>
Add DeepSeek-R1 escalation policy slide to deck (slide 8)
Seven explicit triggers + cost framing + UI surfacing. Pre-defense.
Pushes PyRIT framework slide from 8 to 9; downstream renumbering applies.
</commit_message>
<xml_diff>
--- a/ARCHITECTURE_DEFENSE.pptx
+++ b/ARCHITECTURE_DEFENSE.pptx
@@ -22,6 +22,7 @@
     <p:sldId id="270" r:id="rId21"/>
     <p:sldId id="271" r:id="rId22"/>
     <p:sldId id="272" r:id="rId23"/>
+    <p:sldId id="273" r:id="rId24"/>
   </p:sldIdLst>
   <p:sldSz cx="12191695" cy="6858000" type="screen4x3"/>
   <p:notesSz cx="6858000" cy="9144000"/>
@@ -3343,7 +3344,7 @@
               </a:defRPr>
             </a:pPr>
             <a:r>
-              <a:t>Regression harness — deterministic where it counts</a:t>
+              <a:t>Orchestration strategy — what gets tested next</a:t>
             </a:r>
           </a:p>
         </p:txBody>
@@ -3381,7 +3382,52 @@
               </a:defRPr>
             </a:pPr>
             <a:r>
-              <a:t>• Two assertion types:</a:t>
+              <a:t>• Coverage matrix: 6 categories × ~30 subcategories, each cell tracks cases-run, recent pass-rate, severity weight.</a:t>
+            </a:r>
+          </a:p>
+          <a:p>
+            <a:pPr>
+              <a:spcAft>
+                <a:spcPts val="600"/>
+              </a:spcAft>
+              <a:defRPr sz="2000">
+                <a:solidFill>
+                  <a:srgbClr val="1A2B4C"/>
+                </a:solidFill>
+              </a:defRPr>
+            </a:pPr>
+            <a:r>
+              <a:t>• Priority score per cell = severity × (1 − coverage_ratio) + 0.4 × recent_failure_rate + 0.3 × time_since_last.</a:t>
+            </a:r>
+          </a:p>
+          <a:p>
+            <a:pPr>
+              <a:spcAft>
+                <a:spcPts val="600"/>
+              </a:spcAft>
+              <a:defRPr sz="2000">
+                <a:solidFill>
+                  <a:srgbClr val="1A2B4C"/>
+                </a:solidFill>
+              </a:defRPr>
+            </a:pPr>
+            <a:r>
+              <a:t>• Campaign halts when 30-attack rolling success rate &lt; 2% AND &gt; $5 spent.</a:t>
+            </a:r>
+          </a:p>
+          <a:p>
+            <a:pPr>
+              <a:spcAft>
+                <a:spcPts val="600"/>
+              </a:spcAft>
+              <a:defRPr sz="2000">
+                <a:solidFill>
+                  <a:srgbClr val="1A2B4C"/>
+                </a:solidFill>
+              </a:defRPr>
+            </a:pPr>
+            <a:r>
+              <a:t>• Hard caps enforced in harness, not trusted to agent prompts:</a:t>
             </a:r>
           </a:p>
           <a:p>
@@ -3396,22 +3442,7 @@
               </a:defRPr>
             </a:pPr>
             <a:r>
-              <a:t>    – DETERMINISTIC (preferred): regex on response, structural JSON check, tool-call audit, PHI byte-equality. Cheap, fast, no drift.</a:t>
-            </a:r>
-          </a:p>
-          <a:p>
-            <a:pPr>
-              <a:spcAft>
-                <a:spcPts val="200"/>
-              </a:spcAft>
-              <a:defRPr sz="1600">
-                <a:solidFill>
-                  <a:srgbClr val="555555"/>
-                </a:solidFill>
-              </a:defRPr>
-            </a:pPr>
-            <a:r>
-              <a:t>    – JUDGED (only when semantic): re-runs the original Judge prompt. Tracked separately because of drift risk.</a:t>
+              <a:t>    – Per-campaign USD cap. Per-day global USD cap. Per-target QPS token-bucket.</a:t>
             </a:r>
           </a:p>
           <a:p>
@@ -3426,52 +3457,7 @@
               </a:defRPr>
             </a:pPr>
             <a:r>
-              <a:t>• Anti-Goodhart controls:</a:t>
-            </a:r>
-          </a:p>
-          <a:p>
-            <a:pPr>
-              <a:spcAft>
-                <a:spcPts val="200"/>
-              </a:spcAft>
-              <a:defRPr sz="1600">
-                <a:solidFill>
-                  <a:srgbClr val="555555"/>
-                </a:solidFill>
-              </a:defRPr>
-            </a:pPr>
-            <a:r>
-              <a:t>    – Every case carries a negative control — a benign prompt that must keep passing. Invalidates 'pass' if it breaks.</a:t>
-            </a:r>
-          </a:p>
-          <a:p>
-            <a:pPr>
-              <a:spcAft>
-                <a:spcPts val="200"/>
-              </a:spcAft>
-              <a:defRPr sz="1600">
-                <a:solidFill>
-                  <a:srgbClr val="555555"/>
-                </a:solidFill>
-              </a:defRPr>
-            </a:pPr>
-            <a:r>
-              <a:t>    – Promotion stores the original rubric version. Drift &gt; 2 minor versions → re-run with original rubric + report both.</a:t>
-            </a:r>
-          </a:p>
-          <a:p>
-            <a:pPr>
-              <a:spcAft>
-                <a:spcPts val="600"/>
-              </a:spcAft>
-              <a:defRPr sz="2000">
-                <a:solidFill>
-                  <a:srgbClr val="1A2B4C"/>
-                </a:solidFill>
-              </a:defRPr>
-            </a:pPr>
-            <a:r>
-              <a:t>• Spec gotcha avoided: a test that 'passes because model behavior changed' is worse than no test.</a:t>
+              <a:t>• Regression runs auto-trigger on target deploys (CircleCI pre-`hold-qa` job calls /regression-runs).</a:t>
             </a:r>
           </a:p>
         </p:txBody>
@@ -3567,7 +3553,7 @@
               </a:defRPr>
             </a:pPr>
             <a:r>
-              <a:t>CI/CD integration — gating qa/prod promotions</a:t>
+              <a:t>Regression harness — deterministic where it counts</a:t>
             </a:r>
           </a:p>
         </p:txBody>
@@ -3605,7 +3591,37 @@
               </a:defRPr>
             </a:pPr>
             <a:r>
-              <a:t>• Pre-`hold-qa` CircleCI job calls deployed adversary service's POST /regression-runs.</a:t>
+              <a:t>• Two assertion types:</a:t>
+            </a:r>
+          </a:p>
+          <a:p>
+            <a:pPr>
+              <a:spcAft>
+                <a:spcPts val="200"/>
+              </a:spcAft>
+              <a:defRPr sz="1600">
+                <a:solidFill>
+                  <a:srgbClr val="555555"/>
+                </a:solidFill>
+              </a:defRPr>
+            </a:pPr>
+            <a:r>
+              <a:t>    – DETERMINISTIC (preferred): regex on response, structural JSON check, tool-call audit, PHI byte-equality. Cheap, fast, no drift.</a:t>
+            </a:r>
+          </a:p>
+          <a:p>
+            <a:pPr>
+              <a:spcAft>
+                <a:spcPts val="200"/>
+              </a:spcAft>
+              <a:defRPr sz="1600">
+                <a:solidFill>
+                  <a:srgbClr val="555555"/>
+                </a:solidFill>
+              </a:defRPr>
+            </a:pPr>
+            <a:r>
+              <a:t>    – JUDGED (only when semantic): re-runs the original Judge prompt. Tracked separately because of drift risk.</a:t>
             </a:r>
           </a:p>
           <a:p>
@@ -3620,7 +3636,37 @@
               </a:defRPr>
             </a:pPr>
             <a:r>
-              <a:t>• Dev auto-deploys ungated (fast inner loop preserved). qa and prod promotions are gated.</a:t>
+              <a:t>• Anti-Goodhart controls:</a:t>
+            </a:r>
+          </a:p>
+          <a:p>
+            <a:pPr>
+              <a:spcAft>
+                <a:spcPts val="200"/>
+              </a:spcAft>
+              <a:defRPr sz="1600">
+                <a:solidFill>
+                  <a:srgbClr val="555555"/>
+                </a:solidFill>
+              </a:defRPr>
+            </a:pPr>
+            <a:r>
+              <a:t>    – Every case carries a negative control — a benign prompt that must keep passing. Invalidates 'pass' if it breaks.</a:t>
+            </a:r>
+          </a:p>
+          <a:p>
+            <a:pPr>
+              <a:spcAft>
+                <a:spcPts val="200"/>
+              </a:spcAft>
+              <a:defRPr sz="1600">
+                <a:solidFill>
+                  <a:srgbClr val="555555"/>
+                </a:solidFill>
+              </a:defRPr>
+            </a:pPr>
+            <a:r>
+              <a:t>    – Promotion stores the original rubric version. Drift &gt; 2 minor versions → re-run with original rubric + report both.</a:t>
             </a:r>
           </a:p>
           <a:p>
@@ -3635,72 +3681,7 @@
               </a:defRPr>
             </a:pPr>
             <a:r>
-              <a:t>• Fail if: any new HIGH-severity regression, OR overall pass rate drops &gt;5%, OR cost-per-cycle on target rises &gt;10%.</a:t>
-            </a:r>
-          </a:p>
-          <a:p>
-            <a:pPr>
-              <a:spcAft>
-                <a:spcPts val="600"/>
-              </a:spcAft>
-              <a:defRPr sz="2000">
-                <a:solidFill>
-                  <a:srgbClr val="1A2B4C"/>
-                </a:solidFill>
-              </a:defRPr>
-            </a:pPr>
-            <a:r>
-              <a:t>• Bounded to ~3-5 min — promotion-gate suite is the deterministic subset; full LLM campaign runs async.</a:t>
-            </a:r>
-          </a:p>
-          <a:p>
-            <a:pPr>
-              <a:spcAft>
-                <a:spcPts val="600"/>
-              </a:spcAft>
-              <a:defRPr sz="2000">
-                <a:solidFill>
-                  <a:srgbClr val="1A2B4C"/>
-                </a:solidFill>
-              </a:defRPr>
-            </a:pPr>
-            <a:r>
-              <a:t>• Emergency bypass: `[adversarial-bypass]` commit-msg convention + audit-trail-logged justification.</a:t>
-            </a:r>
-          </a:p>
-        </p:txBody>
-      </p:sp>
-      <p:sp>
-        <p:nvSpPr>
-          <p:cNvPr id="5" name="TextBox 4"/>
-          <p:cNvSpPr txBox="1"/>
-          <p:nvPr/>
-        </p:nvSpPr>
-        <p:spPr>
-          <a:xfrm>
-            <a:off x="457200" y="6355080"/>
-            <a:ext cx="11247120" cy="365760"/>
-          </a:xfrm>
-          <a:prstGeom prst="rect">
-            <a:avLst/>
-          </a:prstGeom>
-          <a:noFill/>
-        </p:spPr>
-        <p:txBody>
-          <a:bodyPr wrap="none">
-            <a:spAutoFit/>
-          </a:bodyPr>
-          <a:lstStyle/>
-          <a:p>
-            <a:pPr algn="l">
-              <a:defRPr sz="1100">
-                <a:solidFill>
-                  <a:srgbClr val="555555"/>
-                </a:solidFill>
-              </a:defRPr>
-            </a:pPr>
-            <a:r>
-              <a:t>Implementation Option A: CircleCI calls the adversary service via API. Suite is pinned to a tag, not main.</a:t>
+              <a:t>• Spec gotcha avoided: a test that 'passes because model behavior changed' is worse than no test.</a:t>
             </a:r>
           </a:p>
         </p:txBody>
@@ -3796,7 +3777,7 @@
               </a:defRPr>
             </a:pPr>
             <a:r>
-              <a:t>Human-facing UI — Next.js dashboard</a:t>
+              <a:t>CI/CD integration — gating qa/prod promotions</a:t>
             </a:r>
           </a:p>
         </p:txBody>
@@ -3834,7 +3815,7 @@
               </a:defRPr>
             </a:pPr>
             <a:r>
-              <a:t>• Two operator paths into the platform: CI auto-runs (previous slide) AND a human UI.</a:t>
+              <a:t>• Pre-`hold-qa` CircleCI job calls deployed adversary service's POST /regression-runs.</a:t>
             </a:r>
           </a:p>
           <a:p>
@@ -3849,7 +3830,7 @@
               </a:defRPr>
             </a:pPr>
             <a:r>
-              <a:t>• Stack: Next.js 15 (App Router) + TypeScript + Tailwind + shadcn/ui + TanStack Query + recharts. SSE for live verdict streaming.</a:t>
+              <a:t>• Dev auto-deploys ungated (fast inner loop preserved). qa and prod promotions are gated.</a:t>
             </a:r>
           </a:p>
           <a:p>
@@ -3864,112 +3845,7 @@
               </a:defRPr>
             </a:pPr>
             <a:r>
-              <a:t>• Pages — each maps to a user role from USERS.md:</a:t>
-            </a:r>
-          </a:p>
-          <a:p>
-            <a:pPr>
-              <a:spcAft>
-                <a:spcPts val="200"/>
-              </a:spcAft>
-              <a:defRPr sz="1600">
-                <a:solidFill>
-                  <a:srgbClr val="555555"/>
-                </a:solidFill>
-              </a:defRPr>
-            </a:pPr>
-            <a:r>
-              <a:t>    – / Dashboard — open findings, last-24h runs, coverage heatmap, current spend (Security Engineer)</a:t>
-            </a:r>
-          </a:p>
-          <a:p>
-            <a:pPr>
-              <a:spcAft>
-                <a:spcPts val="200"/>
-              </a:spcAft>
-              <a:defRPr sz="1600">
-                <a:solidFill>
-                  <a:srgbClr val="555555"/>
-                </a:solidFill>
-              </a:defRPr>
-            </a:pPr>
-            <a:r>
-              <a:t>    – /run — Ad hoc campaign: target + categories + budget → kick off → live verdict stream (Security Engineer)</a:t>
-            </a:r>
-          </a:p>
-          <a:p>
-            <a:pPr>
-              <a:spcAft>
-                <a:spcPts val="200"/>
-              </a:spcAft>
-              <a:defRPr sz="1600">
-                <a:solidFill>
-                  <a:srgbClr val="555555"/>
-                </a:solidFill>
-              </a:defRPr>
-            </a:pPr>
-            <a:r>
-              <a:t>    – /coverage — 6×30 matrix of category × subcategory with case counts, pass-rate, time-since-last (Security Engineer, CISO)</a:t>
-            </a:r>
-          </a:p>
-          <a:p>
-            <a:pPr>
-              <a:spcAft>
-                <a:spcPts val="200"/>
-              </a:spcAft>
-              <a:defRPr sz="1600">
-                <a:solidFill>
-                  <a:srgbClr val="555555"/>
-                </a:solidFill>
-              </a:defRPr>
-            </a:pPr>
-            <a:r>
-              <a:t>    – /findings + /findings/VULN-NNNN — searchable list, drafts queue with approve/reject gate, single-finding repro (All)</a:t>
-            </a:r>
-          </a:p>
-          <a:p>
-            <a:pPr>
-              <a:spcAft>
-                <a:spcPts val="200"/>
-              </a:spcAft>
-              <a:defRPr sz="1600">
-                <a:solidFill>
-                  <a:srgbClr val="555555"/>
-                </a:solidFill>
-              </a:defRPr>
-            </a:pPr>
-            <a:r>
-              <a:t>    – /orchestrator — pause/resume, bump priorities, change budget caps (Security Engineer)</a:t>
-            </a:r>
-          </a:p>
-          <a:p>
-            <a:pPr>
-              <a:spcAft>
-                <a:spcPts val="200"/>
-              </a:spcAft>
-              <a:defRPr sz="1600">
-                <a:solidFill>
-                  <a:srgbClr val="555555"/>
-                </a:solidFill>
-              </a:defRPr>
-            </a:pPr>
-            <a:r>
-              <a:t>    – /runs/&lt;campaign_id&gt; — every attack, every verdict, jump to Langfuse trace (All)</a:t>
-            </a:r>
-          </a:p>
-          <a:p>
-            <a:pPr>
-              <a:spcAft>
-                <a:spcPts val="200"/>
-              </a:spcAft>
-              <a:defRPr sz="1600">
-                <a:solidFill>
-                  <a:srgbClr val="555555"/>
-                </a:solidFill>
-              </a:defRPr>
-            </a:pPr>
-            <a:r>
-              <a:t>    – /dashboard/exec — resilience trend lines + audit export (CISO)</a:t>
+              <a:t>• Fail if: any new HIGH-severity regression, OR overall pass rate drops &gt;5%, OR cost-per-cycle on target rises &gt;10%.</a:t>
             </a:r>
           </a:p>
           <a:p>
@@ -3984,7 +3860,7 @@
               </a:defRPr>
             </a:pPr>
             <a:r>
-              <a:t>• Standalone Next.js app, not iframe-embedded — this is a separate application from the W2 OpenEMR frontend.</a:t>
+              <a:t>• Bounded to ~3-5 min — promotion-gate suite is the deterministic subset; full LLM campaign runs async.</a:t>
             </a:r>
           </a:p>
           <a:p>
@@ -3999,7 +3875,7 @@
               </a:defRPr>
             </a:pPr>
             <a:r>
-              <a:t>• Deployed as `adversary-ui` Railway service. SSE endpoint backed by FastAPI on `adversary-agent`.</a:t>
+              <a:t>• Emergency bypass: `[adversarial-bypass]` commit-msg convention + audit-trail-logged justification.</a:t>
             </a:r>
           </a:p>
         </p:txBody>
@@ -4034,7 +3910,7 @@
               </a:defRPr>
             </a:pPr>
             <a:r>
-              <a:t>The CI path makes promotions safer. The UI path makes findings actionable — same data substrate (Postgres + Langfuse), different consumers.</a:t>
+              <a:t>Implementation Option A: CircleCI calls the adversary service via API. Suite is pinned to a tag, not main.</a:t>
             </a:r>
           </a:p>
         </p:txBody>
@@ -4130,7 +4006,7 @@
               </a:defRPr>
             </a:pPr>
             <a:r>
-              <a:t>Trust &amp; safety for the platform itself</a:t>
+              <a:t>Human-facing UI — Next.js dashboard</a:t>
             </a:r>
           </a:p>
         </p:txBody>
@@ -4168,7 +4044,37 @@
               </a:defRPr>
             </a:pPr>
             <a:r>
-              <a:t>• Target-host allowlist (harness/executor.py) — defense of ARCHITECTURE.md §13:</a:t>
+              <a:t>• Two operator paths into the platform: CI auto-runs (previous slide) AND a human UI.</a:t>
+            </a:r>
+          </a:p>
+          <a:p>
+            <a:pPr>
+              <a:spcAft>
+                <a:spcPts val="600"/>
+              </a:spcAft>
+              <a:defRPr sz="2000">
+                <a:solidFill>
+                  <a:srgbClr val="1A2B4C"/>
+                </a:solidFill>
+              </a:defRPr>
+            </a:pPr>
+            <a:r>
+              <a:t>• Stack: Next.js 15 (App Router) + TypeScript + Tailwind + shadcn/ui + TanStack Query + recharts. SSE for live verdict streaming.</a:t>
+            </a:r>
+          </a:p>
+          <a:p>
+            <a:pPr>
+              <a:spcAft>
+                <a:spcPts val="600"/>
+              </a:spcAft>
+              <a:defRPr sz="2000">
+                <a:solidFill>
+                  <a:srgbClr val="1A2B4C"/>
+                </a:solidFill>
+              </a:defRPr>
+            </a:pPr>
+            <a:r>
+              <a:t>• Pages — each maps to a user role from USERS.md:</a:t>
             </a:r>
           </a:p>
           <a:p>
@@ -4183,7 +4089,7 @@
               </a:defRPr>
             </a:pPr>
             <a:r>
-              <a:t>    – Authorized: copilot-agent-production-41de.up.railway.app + qa + dev + localhost. Window: 2026-05-11 → 2026-05-22.</a:t>
+              <a:t>    – / Dashboard — open findings, last-24h runs, coverage heatmap, current spend (Security Engineer)</a:t>
             </a:r>
           </a:p>
           <a:p>
@@ -4198,7 +4104,82 @@
               </a:defRPr>
             </a:pPr>
             <a:r>
-              <a:t>    – Any HTTP call outside the allowlist hard-errors before bytes leave the platform.</a:t>
+              <a:t>    – /run — Ad hoc campaign: target + categories + budget → kick off → live verdict stream (Security Engineer)</a:t>
+            </a:r>
+          </a:p>
+          <a:p>
+            <a:pPr>
+              <a:spcAft>
+                <a:spcPts val="200"/>
+              </a:spcAft>
+              <a:defRPr sz="1600">
+                <a:solidFill>
+                  <a:srgbClr val="555555"/>
+                </a:solidFill>
+              </a:defRPr>
+            </a:pPr>
+            <a:r>
+              <a:t>    – /coverage — 6×30 matrix of category × subcategory with case counts, pass-rate, time-since-last (Security Engineer, CISO)</a:t>
+            </a:r>
+          </a:p>
+          <a:p>
+            <a:pPr>
+              <a:spcAft>
+                <a:spcPts val="200"/>
+              </a:spcAft>
+              <a:defRPr sz="1600">
+                <a:solidFill>
+                  <a:srgbClr val="555555"/>
+                </a:solidFill>
+              </a:defRPr>
+            </a:pPr>
+            <a:r>
+              <a:t>    – /findings + /findings/VULN-NNNN — searchable list, drafts queue with approve/reject gate, single-finding repro (All)</a:t>
+            </a:r>
+          </a:p>
+          <a:p>
+            <a:pPr>
+              <a:spcAft>
+                <a:spcPts val="200"/>
+              </a:spcAft>
+              <a:defRPr sz="1600">
+                <a:solidFill>
+                  <a:srgbClr val="555555"/>
+                </a:solidFill>
+              </a:defRPr>
+            </a:pPr>
+            <a:r>
+              <a:t>    – /orchestrator — pause/resume, bump priorities, change budget caps (Security Engineer)</a:t>
+            </a:r>
+          </a:p>
+          <a:p>
+            <a:pPr>
+              <a:spcAft>
+                <a:spcPts val="200"/>
+              </a:spcAft>
+              <a:defRPr sz="1600">
+                <a:solidFill>
+                  <a:srgbClr val="555555"/>
+                </a:solidFill>
+              </a:defRPr>
+            </a:pPr>
+            <a:r>
+              <a:t>    – /runs/&lt;campaign_id&gt; — every attack, every verdict, jump to Langfuse trace (All)</a:t>
+            </a:r>
+          </a:p>
+          <a:p>
+            <a:pPr>
+              <a:spcAft>
+                <a:spcPts val="200"/>
+              </a:spcAft>
+              <a:defRPr sz="1600">
+                <a:solidFill>
+                  <a:srgbClr val="555555"/>
+                </a:solidFill>
+              </a:defRPr>
+            </a:pPr>
+            <a:r>
+              <a:t>    – /dashboard/exec — resilience trend lines + audit export (CISO)</a:t>
             </a:r>
           </a:p>
           <a:p>
@@ -4213,82 +4194,57 @@
               </a:defRPr>
             </a:pPr>
             <a:r>
-              <a:t>• Human gates kept exactly where they belong:</a:t>
-            </a:r>
-          </a:p>
-          <a:p>
-            <a:pPr>
-              <a:spcAft>
-                <a:spcPts val="200"/>
-              </a:spcAft>
-              <a:defRPr sz="1600">
+              <a:t>• Standalone Next.js app, not iframe-embedded — this is a separate application from the W2 OpenEMR frontend.</a:t>
+            </a:r>
+          </a:p>
+          <a:p>
+            <a:pPr>
+              <a:spcAft>
+                <a:spcPts val="600"/>
+              </a:spcAft>
+              <a:defRPr sz="2000">
+                <a:solidFill>
+                  <a:srgbClr val="1A2B4C"/>
+                </a:solidFill>
+              </a:defRPr>
+            </a:pPr>
+            <a:r>
+              <a:t>• Deployed as `adversary-ui` Railway service. SSE endpoint backed by FastAPI on `adversary-agent`.</a:t>
+            </a:r>
+          </a:p>
+        </p:txBody>
+      </p:sp>
+      <p:sp>
+        <p:nvSpPr>
+          <p:cNvPr id="5" name="TextBox 4"/>
+          <p:cNvSpPr txBox="1"/>
+          <p:nvPr/>
+        </p:nvSpPr>
+        <p:spPr>
+          <a:xfrm>
+            <a:off x="457200" y="6355080"/>
+            <a:ext cx="11247120" cy="365760"/>
+          </a:xfrm>
+          <a:prstGeom prst="rect">
+            <a:avLst/>
+          </a:prstGeom>
+          <a:noFill/>
+        </p:spPr>
+        <p:txBody>
+          <a:bodyPr wrap="none">
+            <a:spAutoFit/>
+          </a:bodyPr>
+          <a:lstStyle/>
+          <a:p>
+            <a:pPr algn="l">
+              <a:defRPr sz="1100">
                 <a:solidFill>
                   <a:srgbClr val="555555"/>
                 </a:solidFill>
               </a:defRPr>
             </a:pPr>
             <a:r>
-              <a:t>    – Critical/high finding publication · rubric changes · allowlist edits · prod-target campaigns above $ cap · `[adversarial-bypass]` force-promote.</a:t>
-            </a:r>
-          </a:p>
-          <a:p>
-            <a:pPr>
-              <a:spcAft>
-                <a:spcPts val="600"/>
-              </a:spcAft>
-              <a:defRPr sz="2000">
-                <a:solidFill>
-                  <a:srgbClr val="1A2B4C"/>
-                </a:solidFill>
-              </a:defRPr>
-            </a:pPr>
-            <a:r>
-              <a:t>• Autonomy preserved exactly where it should be:</a:t>
-            </a:r>
-          </a:p>
-          <a:p>
-            <a:pPr>
-              <a:spcAft>
-                <a:spcPts val="200"/>
-              </a:spcAft>
-              <a:defRPr sz="1600">
-                <a:solidFill>
-                  <a:srgbClr val="555555"/>
-                </a:solidFill>
-              </a:defRPr>
-            </a:pPr>
-            <a:r>
-              <a:t>    – Campaign scheduling · attack mutation · individual judgments · medium/low finding drafts · nightly regressions · coverage priorities.</a:t>
-            </a:r>
-          </a:p>
-          <a:p>
-            <a:pPr>
-              <a:spcAft>
-                <a:spcPts val="600"/>
-              </a:spcAft>
-              <a:defRPr sz="2000">
-                <a:solidFill>
-                  <a:srgbClr val="1A2B4C"/>
-                </a:solidFill>
-              </a:defRPr>
-            </a:pPr>
-            <a:r>
-              <a:t>• No autonomous remediation — spec is explicit, and an agent that can push fixes can introduce vulnerabilities.</a:t>
-            </a:r>
-          </a:p>
-          <a:p>
-            <a:pPr>
-              <a:spcAft>
-                <a:spcPts val="600"/>
-              </a:spcAft>
-              <a:defRPr sz="2000">
-                <a:solidFill>
-                  <a:srgbClr val="1A2B4C"/>
-                </a:solidFill>
-              </a:defRPr>
-            </a:pPr>
-            <a:r>
-              <a:t>• Immutable audit log on every campaign, attack, verdict, publish.</a:t>
+              <a:t>The CI path makes promotions safer. The UI path makes findings actionable — same data substrate (Postgres + Langfuse), different consumers.</a:t>
             </a:r>
           </a:p>
         </p:txBody>
@@ -4384,7 +4340,7 @@
               </a:defRPr>
             </a:pPr>
             <a:r>
-              <a:t>Observability — Langfuse, tagged by agent_role</a:t>
+              <a:t>Trust &amp; safety for the platform itself</a:t>
             </a:r>
           </a:p>
         </p:txBody>
@@ -4422,7 +4378,37 @@
               </a:defRPr>
             </a:pPr>
             <a:r>
-              <a:t>• Self-hosted Langfuse (reuse W2 deployment) — no offensive-security trace leaves the platform.</a:t>
+              <a:t>• Target-host allowlist (harness/executor.py) — defense of ARCHITECTURE.md §13:</a:t>
+            </a:r>
+          </a:p>
+          <a:p>
+            <a:pPr>
+              <a:spcAft>
+                <a:spcPts val="200"/>
+              </a:spcAft>
+              <a:defRPr sz="1600">
+                <a:solidFill>
+                  <a:srgbClr val="555555"/>
+                </a:solidFill>
+              </a:defRPr>
+            </a:pPr>
+            <a:r>
+              <a:t>    – Authorized: copilot-agent-production-41de.up.railway.app + qa + dev + localhost. Window: 2026-05-11 → 2026-05-22.</a:t>
+            </a:r>
+          </a:p>
+          <a:p>
+            <a:pPr>
+              <a:spcAft>
+                <a:spcPts val="200"/>
+              </a:spcAft>
+              <a:defRPr sz="1600">
+                <a:solidFill>
+                  <a:srgbClr val="555555"/>
+                </a:solidFill>
+              </a:defRPr>
+            </a:pPr>
+            <a:r>
+              <a:t>    – Any HTTP call outside the allowlist hard-errors before bytes leave the platform.</a:t>
             </a:r>
           </a:p>
           <a:p>
@@ -4437,7 +4423,22 @@
               </a:defRPr>
             </a:pPr>
             <a:r>
-              <a:t>• Every call carries: agent_role, campaign_id, attack_category, attack_subcategory, target_sha, verdict.</a:t>
+              <a:t>• Human gates kept exactly where they belong:</a:t>
+            </a:r>
+          </a:p>
+          <a:p>
+            <a:pPr>
+              <a:spcAft>
+                <a:spcPts val="200"/>
+              </a:spcAft>
+              <a:defRPr sz="1600">
+                <a:solidFill>
+                  <a:srgbClr val="555555"/>
+                </a:solidFill>
+              </a:defRPr>
+            </a:pPr>
+            <a:r>
+              <a:t>    – Critical/high finding publication · rubric changes · allowlist edits · prod-target campaigns above $ cap · `[adversarial-bypass]` force-promote.</a:t>
             </a:r>
           </a:p>
           <a:p>
@@ -4452,7 +4453,7 @@
               </a:defRPr>
             </a:pPr>
             <a:r>
-              <a:t>• Six required questions, all answerable from the dashboard:</a:t>
+              <a:t>• Autonomy preserved exactly where it should be:</a:t>
             </a:r>
           </a:p>
           <a:p>
@@ -4467,82 +4468,7 @@
               </a:defRPr>
             </a:pPr>
             <a:r>
-              <a:t>    – Which categories have been tested, how many cases each?</a:t>
-            </a:r>
-          </a:p>
-          <a:p>
-            <a:pPr>
-              <a:spcAft>
-                <a:spcPts val="200"/>
-              </a:spcAft>
-              <a:defRPr sz="1600">
-                <a:solidFill>
-                  <a:srgbClr val="555555"/>
-                </a:solidFill>
-              </a:defRPr>
-            </a:pPr>
-            <a:r>
-              <a:t>    – Pass/fail rate by category and target version?</a:t>
-            </a:r>
-          </a:p>
-          <a:p>
-            <a:pPr>
-              <a:spcAft>
-                <a:spcPts val="200"/>
-              </a:spcAft>
-              <a:defRPr sz="1600">
-                <a:solidFill>
-                  <a:srgbClr val="555555"/>
-                </a:solidFill>
-              </a:defRPr>
-            </a:pPr>
-            <a:r>
-              <a:t>    – Is the target getting more or less resilient over time?</a:t>
-            </a:r>
-          </a:p>
-          <a:p>
-            <a:pPr>
-              <a:spcAft>
-                <a:spcPts val="200"/>
-              </a:spcAft>
-              <a:defRPr sz="1600">
-                <a:solidFill>
-                  <a:srgbClr val="555555"/>
-                </a:solidFill>
-              </a:defRPr>
-            </a:pPr>
-            <a:r>
-              <a:t>    – Open vs in-progress vs resolved findings?</a:t>
-            </a:r>
-          </a:p>
-          <a:p>
-            <a:pPr>
-              <a:spcAft>
-                <a:spcPts val="200"/>
-              </a:spcAft>
-              <a:defRPr sz="1600">
-                <a:solidFill>
-                  <a:srgbClr val="555555"/>
-                </a:solidFill>
-              </a:defRPr>
-            </a:pPr>
-            <a:r>
-              <a:t>    – Run cost, scaling rate?</a:t>
-            </a:r>
-          </a:p>
-          <a:p>
-            <a:pPr>
-              <a:spcAft>
-                <a:spcPts val="200"/>
-              </a:spcAft>
-              <a:defRPr sz="1600">
-                <a:solidFill>
-                  <a:srgbClr val="555555"/>
-                </a:solidFill>
-              </a:defRPr>
-            </a:pPr>
-            <a:r>
-              <a:t>    – What did each agent do, in what order?</a:t>
+              <a:t>    – Campaign scheduling · attack mutation · individual judgments · medium/low finding drafts · nightly regressions · coverage priorities.</a:t>
             </a:r>
           </a:p>
           <a:p>
@@ -4557,7 +4483,22 @@
               </a:defRPr>
             </a:pPr>
             <a:r>
-              <a:t>• Per-call USD computed from (model, prompt_tokens, completion_tokens) stored on the span.</a:t>
+              <a:t>• No autonomous remediation — spec is explicit, and an agent that can push fixes can introduce vulnerabilities.</a:t>
+            </a:r>
+          </a:p>
+          <a:p>
+            <a:pPr>
+              <a:spcAft>
+                <a:spcPts val="600"/>
+              </a:spcAft>
+              <a:defRPr sz="2000">
+                <a:solidFill>
+                  <a:srgbClr val="1A2B4C"/>
+                </a:solidFill>
+              </a:defRPr>
+            </a:pPr>
+            <a:r>
+              <a:t>• Immutable audit log on every campaign, attack, verdict, publish.</a:t>
             </a:r>
           </a:p>
         </p:txBody>
@@ -4653,7 +4594,7 @@
               </a:defRPr>
             </a:pPr>
             <a:r>
-              <a:t>Cost at scale (~5% pass rate, 2:1 mutation:seed ratio)</a:t>
+              <a:t>Observability — Langfuse, tagged by agent_role</a:t>
             </a:r>
           </a:p>
         </p:txBody>
@@ -4691,7 +4632,7 @@
               </a:defRPr>
             </a:pPr>
             <a:r>
-              <a:t>• 100 runs → ~$0.70 — no bottleneck.</a:t>
+              <a:t>• Self-hosted Langfuse (reuse W2 deployment) — no offensive-security trace leaves the platform.</a:t>
             </a:r>
           </a:p>
           <a:p>
@@ -4706,7 +4647,7 @@
               </a:defRPr>
             </a:pPr>
             <a:r>
-              <a:t>• 1K runs → ~$7 — bottleneck: local Ollama / RunPod throughput.</a:t>
+              <a:t>• Every call carries: agent_role, campaign_id, attack_category, attack_subcategory, target_sha, verdict.</a:t>
             </a:r>
           </a:p>
           <a:p>
@@ -4721,7 +4662,97 @@
               </a:defRPr>
             </a:pPr>
             <a:r>
-              <a:t>• 10K runs → ~$70 — bottleneck: Judge concurrency / Anthropic rate limits.</a:t>
+              <a:t>• Six required questions, all answerable from the dashboard:</a:t>
+            </a:r>
+          </a:p>
+          <a:p>
+            <a:pPr>
+              <a:spcAft>
+                <a:spcPts val="200"/>
+              </a:spcAft>
+              <a:defRPr sz="1600">
+                <a:solidFill>
+                  <a:srgbClr val="555555"/>
+                </a:solidFill>
+              </a:defRPr>
+            </a:pPr>
+            <a:r>
+              <a:t>    – Which categories have been tested, how many cases each?</a:t>
+            </a:r>
+          </a:p>
+          <a:p>
+            <a:pPr>
+              <a:spcAft>
+                <a:spcPts val="200"/>
+              </a:spcAft>
+              <a:defRPr sz="1600">
+                <a:solidFill>
+                  <a:srgbClr val="555555"/>
+                </a:solidFill>
+              </a:defRPr>
+            </a:pPr>
+            <a:r>
+              <a:t>    – Pass/fail rate by category and target version?</a:t>
+            </a:r>
+          </a:p>
+          <a:p>
+            <a:pPr>
+              <a:spcAft>
+                <a:spcPts val="200"/>
+              </a:spcAft>
+              <a:defRPr sz="1600">
+                <a:solidFill>
+                  <a:srgbClr val="555555"/>
+                </a:solidFill>
+              </a:defRPr>
+            </a:pPr>
+            <a:r>
+              <a:t>    – Is the target getting more or less resilient over time?</a:t>
+            </a:r>
+          </a:p>
+          <a:p>
+            <a:pPr>
+              <a:spcAft>
+                <a:spcPts val="200"/>
+              </a:spcAft>
+              <a:defRPr sz="1600">
+                <a:solidFill>
+                  <a:srgbClr val="555555"/>
+                </a:solidFill>
+              </a:defRPr>
+            </a:pPr>
+            <a:r>
+              <a:t>    – Open vs in-progress vs resolved findings?</a:t>
+            </a:r>
+          </a:p>
+          <a:p>
+            <a:pPr>
+              <a:spcAft>
+                <a:spcPts val="200"/>
+              </a:spcAft>
+              <a:defRPr sz="1600">
+                <a:solidFill>
+                  <a:srgbClr val="555555"/>
+                </a:solidFill>
+              </a:defRPr>
+            </a:pPr>
+            <a:r>
+              <a:t>    – Run cost, scaling rate?</a:t>
+            </a:r>
+          </a:p>
+          <a:p>
+            <a:pPr>
+              <a:spcAft>
+                <a:spcPts val="200"/>
+              </a:spcAft>
+              <a:defRPr sz="1600">
+                <a:solidFill>
+                  <a:srgbClr val="555555"/>
+                </a:solidFill>
+              </a:defRPr>
+            </a:pPr>
+            <a:r>
+              <a:t>    – What did each agent do, in what order?</a:t>
             </a:r>
           </a:p>
           <a:p>
@@ -4736,82 +4767,7 @@
               </a:defRPr>
             </a:pPr>
             <a:r>
-              <a:t>• 100K runs → ~$700 base — required architectural changes:</a:t>
-            </a:r>
-          </a:p>
-          <a:p>
-            <a:pPr>
-              <a:spcAft>
-                <a:spcPts val="200"/>
-              </a:spcAft>
-              <a:defRPr sz="1600">
-                <a:solidFill>
-                  <a:srgbClr val="555555"/>
-                </a:solidFill>
-              </a:defRPr>
-            </a:pPr>
-            <a:r>
-              <a:t>    – Deterministic pre-filter knocks out ~40% of clearly-failed attacks before Judge sees them.</a:t>
-            </a:r>
-          </a:p>
-          <a:p>
-            <a:pPr>
-              <a:spcAft>
-                <a:spcPts val="200"/>
-              </a:spcAft>
-              <a:defRPr sz="1600">
-                <a:solidFill>
-                  <a:srgbClr val="555555"/>
-                </a:solidFill>
-              </a:defRPr>
-            </a:pPr>
-            <a:r>
-              <a:t>    – Batched Judge calls + sharded Judge instances (one per category).</a:t>
-            </a:r>
-          </a:p>
-          <a:p>
-            <a:pPr>
-              <a:spcAft>
-                <a:spcPts val="200"/>
-              </a:spcAft>
-              <a:defRPr sz="1600">
-                <a:solidFill>
-                  <a:srgbClr val="555555"/>
-                </a:solidFill>
-              </a:defRPr>
-            </a:pPr>
-            <a:r>
-              <a:t>    – Sharded RunPod / always-warm fleet for the 70B abliterated model.</a:t>
-            </a:r>
-          </a:p>
-          <a:p>
-            <a:pPr>
-              <a:spcAft>
-                <a:spcPts val="600"/>
-              </a:spcAft>
-              <a:defRPr sz="2000">
-                <a:solidFill>
-                  <a:srgbClr val="1A2B4C"/>
-                </a:solidFill>
-              </a:defRPr>
-            </a:pPr>
-            <a:r>
-              <a:t>• Cost-per-cycle is dominated by Judge, not Red Team — only because we picked uncensored local for generation.</a:t>
-            </a:r>
-          </a:p>
-          <a:p>
-            <a:pPr>
-              <a:spcAft>
-                <a:spcPts val="600"/>
-              </a:spcAft>
-              <a:defRPr sz="2000">
-                <a:solidFill>
-                  <a:srgbClr val="1A2B4C"/>
-                </a:solidFill>
-              </a:defRPr>
-            </a:pPr>
-            <a:r>
-              <a:t>• Full breakdown in AI_COST_ANALYSIS.md.</a:t>
+              <a:t>• Per-call USD computed from (model, prompt_tokens, completion_tokens) stored on the span.</a:t>
             </a:r>
           </a:p>
         </p:txBody>
@@ -4907,7 +4863,7 @@
               </a:defRPr>
             </a:pPr>
             <a:r>
-              <a:t>Sprint plan (W3 deadlines)</a:t>
+              <a:t>Cost at scale (~5% pass rate, 2:1 mutation:seed ratio)</a:t>
             </a:r>
           </a:p>
         </p:txBody>
@@ -4945,7 +4901,7 @@
               </a:defRPr>
             </a:pPr>
             <a:r>
-              <a:t>• Today (Mon 05-11): architecture defense + THREAT_MODEL.md + USERS.md + initial seeds + Red Team prototype hitting live dev target.</a:t>
+              <a:t>• 100 runs → ~$0.70 — no bottleneck.</a:t>
             </a:r>
           </a:p>
           <a:p>
@@ -4960,7 +4916,7 @@
               </a:defRPr>
             </a:pPr>
             <a:r>
-              <a:t>• Tue 05-12 (MVP): all four agents end-to-end on ≥3 categories, ≥3 vulnerability reports, platform deployed, observability MVP, cost analysis v1.</a:t>
+              <a:t>• 1K runs → ~$7 — bottleneck: local Ollama / RunPod throughput.</a:t>
             </a:r>
           </a:p>
           <a:p>
@@ -4975,7 +4931,7 @@
               </a:defRPr>
             </a:pPr>
             <a:r>
-              <a:t>• Wed 05-13: Orchestrator + coverage matrix + budget caps + regression harness wired to CircleCI pre-`hold-qa`.</a:t>
+              <a:t>• 10K runs → ~$70 — bottleneck: Judge concurrency / Anthropic rate limits.</a:t>
             </a:r>
           </a:p>
           <a:p>
@@ -4990,7 +4946,52 @@
               </a:defRPr>
             </a:pPr>
             <a:r>
-              <a:t>• Thu 05-14: Documentation Agent + full regression integration + UI dashboard polish + bug bash.</a:t>
+              <a:t>• 100K runs → ~$700 base — required architectural changes:</a:t>
+            </a:r>
+          </a:p>
+          <a:p>
+            <a:pPr>
+              <a:spcAft>
+                <a:spcPts val="200"/>
+              </a:spcAft>
+              <a:defRPr sz="1600">
+                <a:solidFill>
+                  <a:srgbClr val="555555"/>
+                </a:solidFill>
+              </a:defRPr>
+            </a:pPr>
+            <a:r>
+              <a:t>    – Deterministic pre-filter knocks out ~40% of clearly-failed attacks before Judge sees them.</a:t>
+            </a:r>
+          </a:p>
+          <a:p>
+            <a:pPr>
+              <a:spcAft>
+                <a:spcPts val="200"/>
+              </a:spcAft>
+              <a:defRPr sz="1600">
+                <a:solidFill>
+                  <a:srgbClr val="555555"/>
+                </a:solidFill>
+              </a:defRPr>
+            </a:pPr>
+            <a:r>
+              <a:t>    – Batched Judge calls + sharded Judge instances (one per category).</a:t>
+            </a:r>
+          </a:p>
+          <a:p>
+            <a:pPr>
+              <a:spcAft>
+                <a:spcPts val="200"/>
+              </a:spcAft>
+              <a:defRPr sz="1600">
+                <a:solidFill>
+                  <a:srgbClr val="555555"/>
+                </a:solidFill>
+              </a:defRPr>
+            </a:pPr>
+            <a:r>
+              <a:t>    – Sharded RunPod / always-warm fleet for the 70B abliterated model.</a:t>
             </a:r>
           </a:p>
           <a:p>
@@ -5005,7 +5006,7 @@
               </a:defRPr>
             </a:pPr>
             <a:r>
-              <a:t>• Fri 05-15 noon (FINAL): demo video, cost projections at 100/1K/10K/100K, README pass, social post.</a:t>
+              <a:t>• Cost-per-cycle is dominated by Judge, not Red Team — only because we picked uncensored local for generation.</a:t>
             </a:r>
           </a:p>
           <a:p>
@@ -5020,7 +5021,7 @@
               </a:defRPr>
             </a:pPr>
             <a:r>
-              <a:t>• Authorization window extends to 2026-05-22 for post-final exploration / replay.</a:t>
+              <a:t>• Full breakdown in AI_COST_ANALYSIS.md.</a:t>
             </a:r>
           </a:p>
         </p:txBody>
@@ -5116,6 +5117,215 @@
               </a:defRPr>
             </a:pPr>
             <a:r>
+              <a:t>Sprint plan (W3 deadlines)</a:t>
+            </a:r>
+          </a:p>
+        </p:txBody>
+      </p:sp>
+      <p:sp>
+        <p:nvSpPr>
+          <p:cNvPr id="4" name="TextBox 3"/>
+          <p:cNvSpPr txBox="1"/>
+          <p:nvPr/>
+        </p:nvSpPr>
+        <p:spPr>
+          <a:xfrm>
+            <a:off x="457200" y="1005840"/>
+            <a:ext cx="11247120" cy="5120640"/>
+          </a:xfrm>
+          <a:prstGeom prst="rect">
+            <a:avLst/>
+          </a:prstGeom>
+          <a:noFill/>
+        </p:spPr>
+        <p:txBody>
+          <a:bodyPr wrap="square">
+            <a:spAutoFit/>
+          </a:bodyPr>
+          <a:lstStyle/>
+          <a:p>
+            <a:pPr>
+              <a:spcAft>
+                <a:spcPts val="600"/>
+              </a:spcAft>
+              <a:defRPr sz="2000">
+                <a:solidFill>
+                  <a:srgbClr val="1A2B4C"/>
+                </a:solidFill>
+              </a:defRPr>
+            </a:pPr>
+            <a:r>
+              <a:t>• Today (Mon 05-11): architecture defense + THREAT_MODEL.md + USERS.md + initial seeds + Red Team prototype hitting live dev target.</a:t>
+            </a:r>
+          </a:p>
+          <a:p>
+            <a:pPr>
+              <a:spcAft>
+                <a:spcPts val="600"/>
+              </a:spcAft>
+              <a:defRPr sz="2000">
+                <a:solidFill>
+                  <a:srgbClr val="1A2B4C"/>
+                </a:solidFill>
+              </a:defRPr>
+            </a:pPr>
+            <a:r>
+              <a:t>• Tue 05-12 (MVP): all four agents end-to-end on ≥3 categories, ≥3 vulnerability reports, platform deployed, observability MVP, cost analysis v1.</a:t>
+            </a:r>
+          </a:p>
+          <a:p>
+            <a:pPr>
+              <a:spcAft>
+                <a:spcPts val="600"/>
+              </a:spcAft>
+              <a:defRPr sz="2000">
+                <a:solidFill>
+                  <a:srgbClr val="1A2B4C"/>
+                </a:solidFill>
+              </a:defRPr>
+            </a:pPr>
+            <a:r>
+              <a:t>• Wed 05-13: Orchestrator + coverage matrix + budget caps + regression harness wired to CircleCI pre-`hold-qa`.</a:t>
+            </a:r>
+          </a:p>
+          <a:p>
+            <a:pPr>
+              <a:spcAft>
+                <a:spcPts val="600"/>
+              </a:spcAft>
+              <a:defRPr sz="2000">
+                <a:solidFill>
+                  <a:srgbClr val="1A2B4C"/>
+                </a:solidFill>
+              </a:defRPr>
+            </a:pPr>
+            <a:r>
+              <a:t>• Thu 05-14: Documentation Agent + full regression integration + UI dashboard polish + bug bash.</a:t>
+            </a:r>
+          </a:p>
+          <a:p>
+            <a:pPr>
+              <a:spcAft>
+                <a:spcPts val="600"/>
+              </a:spcAft>
+              <a:defRPr sz="2000">
+                <a:solidFill>
+                  <a:srgbClr val="1A2B4C"/>
+                </a:solidFill>
+              </a:defRPr>
+            </a:pPr>
+            <a:r>
+              <a:t>• Fri 05-15 noon (FINAL): demo video, cost projections at 100/1K/10K/100K, README pass, social post.</a:t>
+            </a:r>
+          </a:p>
+          <a:p>
+            <a:pPr>
+              <a:spcAft>
+                <a:spcPts val="600"/>
+              </a:spcAft>
+              <a:defRPr sz="2000">
+                <a:solidFill>
+                  <a:srgbClr val="1A2B4C"/>
+                </a:solidFill>
+              </a:defRPr>
+            </a:pPr>
+            <a:r>
+              <a:t>• Authorization window extends to 2026-05-22 for post-final exploration / replay.</a:t>
+            </a:r>
+          </a:p>
+        </p:txBody>
+      </p:sp>
+    </p:spTree>
+  </p:cSld>
+  <p:clrMapOvr>
+    <a:masterClrMapping/>
+  </p:clrMapOvr>
+</p:sld>
+</file>
+
+<file path=ppt/slides/slide18.xml><?xml version="1.0" encoding="utf-8"?>
+<p:sld xmlns:a="http://schemas.openxmlformats.org/drawingml/2006/main" xmlns:p="http://schemas.openxmlformats.org/presentationml/2006/main" xmlns:r="http://schemas.openxmlformats.org/officeDocument/2006/relationships">
+  <p:cSld>
+    <p:spTree>
+      <p:nvGrpSpPr>
+        <p:cNvPr id="1" name=""/>
+        <p:cNvGrpSpPr/>
+        <p:nvPr/>
+      </p:nvGrpSpPr>
+      <p:grpSpPr/>
+      <p:sp>
+        <p:nvSpPr>
+          <p:cNvPr id="2" name="Rectangle 1"/>
+          <p:cNvSpPr/>
+          <p:nvPr/>
+        </p:nvSpPr>
+        <p:spPr>
+          <a:xfrm>
+            <a:off x="0" y="0"/>
+            <a:ext cx="12191695" cy="822960"/>
+          </a:xfrm>
+          <a:prstGeom prst="rect">
+            <a:avLst/>
+          </a:prstGeom>
+          <a:solidFill>
+            <a:srgbClr val="1A2B4C"/>
+          </a:solidFill>
+          <a:ln>
+            <a:noFill/>
+          </a:ln>
+        </p:spPr>
+        <p:style>
+          <a:lnRef idx="1">
+            <a:schemeClr val="accent1"/>
+          </a:lnRef>
+          <a:fillRef idx="3">
+            <a:schemeClr val="accent1"/>
+          </a:fillRef>
+          <a:effectRef idx="2">
+            <a:schemeClr val="accent1"/>
+          </a:effectRef>
+          <a:fontRef idx="minor">
+            <a:schemeClr val="lt1"/>
+          </a:fontRef>
+        </p:style>
+        <p:txBody>
+          <a:bodyPr rtlCol="0" anchor="ctr"/>
+          <a:lstStyle/>
+          <a:p>
+            <a:pPr algn="ctr"/>
+          </a:p>
+        </p:txBody>
+      </p:sp>
+      <p:sp>
+        <p:nvSpPr>
+          <p:cNvPr id="3" name="TextBox 2"/>
+          <p:cNvSpPr txBox="1"/>
+          <p:nvPr/>
+        </p:nvSpPr>
+        <p:spPr>
+          <a:xfrm>
+            <a:off x="457200" y="137160"/>
+            <a:ext cx="11247120" cy="548640"/>
+          </a:xfrm>
+          <a:prstGeom prst="rect">
+            <a:avLst/>
+          </a:prstGeom>
+          <a:noFill/>
+        </p:spPr>
+        <p:txBody>
+          <a:bodyPr wrap="none">
+            <a:spAutoFit/>
+          </a:bodyPr>
+          <a:lstStyle/>
+          <a:p>
+            <a:pPr>
+              <a:defRPr sz="2800" b="1">
+                <a:solidFill>
+                  <a:srgbClr val="FFFFFF"/>
+                </a:solidFill>
+              </a:defRPr>
+            </a:pPr>
+            <a:r>
               <a:t>What I'm prepared to defend</a:t>
             </a:r>
           </a:p>
@@ -8247,7 +8457,7 @@
               </a:defRPr>
             </a:pPr>
             <a:r>
-              <a:t>Framework choice: PyRIT for attack orchestration</a:t>
+              <a:t>DeepSeek-R1 escalation — when and why</a:t>
             </a:r>
           </a:p>
         </p:txBody>
@@ -8285,7 +8495,22 @@
               </a:defRPr>
             </a:pPr>
             <a:r>
-              <a:t>• Multi-turn mutation orchestrators built-in.</a:t>
+              <a:t>• Default attacker is huihui-ai 70B abliterated on RunPod (≈ $0 / token).</a:t>
+            </a:r>
+          </a:p>
+          <a:p>
+            <a:pPr>
+              <a:spcAft>
+                <a:spcPts val="600"/>
+              </a:spcAft>
+              <a:defRPr sz="2000">
+                <a:solidFill>
+                  <a:srgbClr val="1A2B4C"/>
+                </a:solidFill>
+              </a:defRPr>
+            </a:pPr>
+            <a:r>
+              <a:t>• Orchestrator promotes the campaign to DeepSeek-R1 when ANY of:</a:t>
             </a:r>
           </a:p>
           <a:p>
@@ -8300,7 +8525,7 @@
               </a:defRPr>
             </a:pPr>
             <a:r>
-              <a:t>    – TreeOfAttacksWithPruningOrchestrator (TAP): attacker LLM generates → tests → refines based on target responses.</a:t>
+              <a:t>    – 1. Primary refusal rate &gt; 30% over rolling 10 attempts — abliteration isn't perfect; spikes auto-escalate the remaining batch</a:t>
             </a:r>
           </a:p>
           <a:p>
@@ -8315,7 +8540,82 @@
               </a:defRPr>
             </a:pPr>
             <a:r>
-              <a:t>    – CrescendoOrchestrator: gradual multi-turn escalation. ~1000 lines we'd otherwise hand-write and tune.</a:t>
+              <a:t>    – 2. TAP tree depth &gt; 3 with zero Judge-pass — local model is stuck; DeepSeek's reasoning unlocks branches</a:t>
+            </a:r>
+          </a:p>
+          <a:p>
+            <a:pPr>
+              <a:spcAft>
+                <a:spcPts val="200"/>
+              </a:spcAft>
+              <a:defRPr sz="1600">
+                <a:solidFill>
+                  <a:srgbClr val="555555"/>
+                </a:solidFill>
+              </a:defRPr>
+            </a:pPr>
+            <a:r>
+              <a:t>    – 3. Category is reasoning-heavy by default — multi-turn crescendo, staged-reasoning indirect injection, trust-boundary smuggling</a:t>
+            </a:r>
+          </a:p>
+          <a:p>
+            <a:pPr>
+              <a:spcAft>
+                <a:spcPts val="200"/>
+              </a:spcAft>
+              <a:defRPr sz="1600">
+                <a:solidFill>
+                  <a:srgbClr val="555555"/>
+                </a:solidFill>
+              </a:defRPr>
+            </a:pPr>
+            <a:r>
+              <a:t>    – 4. Conversation depth &gt; 4 turns — local context handling degrades; DeepSeek holds the thread better</a:t>
+            </a:r>
+          </a:p>
+          <a:p>
+            <a:pPr>
+              <a:spcAft>
+                <a:spcPts val="200"/>
+              </a:spcAft>
+              <a:defRPr sz="1600">
+                <a:solidFill>
+                  <a:srgbClr val="555555"/>
+                </a:solidFill>
+              </a:defRPr>
+            </a:pPr>
+            <a:r>
+              <a:t>    – 5. Subcategory has sev ≥ 9 AND zero cases — first run on a high-severity blank cell justifies the cents</a:t>
+            </a:r>
+          </a:p>
+          <a:p>
+            <a:pPr>
+              <a:spcAft>
+                <a:spcPts val="200"/>
+              </a:spcAft>
+              <a:defRPr sz="1600">
+                <a:solidFill>
+                  <a:srgbClr val="555555"/>
+                </a:solidFill>
+              </a:defRPr>
+            </a:pPr>
+            <a:r>
+              <a:t>    – 6. Manual override — UI flag on Ad Hoc Run, or per-seed `reasoning_required: true` in YAML</a:t>
+            </a:r>
+          </a:p>
+          <a:p>
+            <a:pPr>
+              <a:spcAft>
+                <a:spcPts val="200"/>
+              </a:spcAft>
+              <a:defRPr sz="1600">
+                <a:solidFill>
+                  <a:srgbClr val="555555"/>
+                </a:solidFill>
+              </a:defRPr>
+            </a:pPr>
+            <a:r>
+              <a:t>    – 7. A/B sample (5% of campaigns) — both attackers run the same seeds; data tunes triggers 1–6 over time</a:t>
             </a:r>
           </a:p>
           <a:p>
@@ -8330,7 +8630,7 @@
               </a:defRPr>
             </a:pPr>
             <a:r>
-              <a:t>• Battle-tested.</a:t>
+              <a:t>• Cost framing: DeepSeek-reasoner ≈ $0.55 / $2.19 per Mtok — ~10× cheaper than Claude or GPT.</a:t>
             </a:r>
           </a:p>
           <a:p>
@@ -8345,7 +8645,7 @@
               </a:defRPr>
             </a:pPr>
             <a:r>
-              <a:t>    – Microsoft's AI Red Team uses it against Copilot, Phi-3, 100+ internal operations. Published paper, MIT-licensed, ~3.8K stars.</a:t>
+              <a:t>    – At 100K runs/month with ~15% escalation rate: ≈ $25–50 / month in DeepSeek spend.</a:t>
             </a:r>
           </a:p>
           <a:p>
@@ -8360,97 +8660,7 @@
               </a:defRPr>
             </a:pPr>
             <a:r>
-              <a:t>• Pluggable target/attacker models.</a:t>
-            </a:r>
-          </a:p>
-          <a:p>
-            <a:pPr>
-              <a:spcAft>
-                <a:spcPts val="200"/>
-              </a:spcAft>
-              <a:defRPr sz="1600">
-                <a:solidFill>
-                  <a:srgbClr val="555555"/>
-                </a:solidFill>
-              </a:defRPr>
-            </a:pPr>
-            <a:r>
-              <a:t>    – Swap RunPod-hosted abliterated Llama → DeepSeek-R1 → anything else by config. Same orchestrator, any OpenAI-compatible endpoint.</a:t>
-            </a:r>
-          </a:p>
-          <a:p>
-            <a:pPr>
-              <a:spcAft>
-                <a:spcPts val="600"/>
-              </a:spcAft>
-              <a:defRPr sz="2000">
-                <a:solidFill>
-                  <a:srgbClr val="1A2B4C"/>
-                </a:solidFill>
-              </a:defRPr>
-            </a:pPr>
-            <a:r>
-              <a:t>• Built-in converters (prompt obfuscation).</a:t>
-            </a:r>
-          </a:p>
-          <a:p>
-            <a:pPr>
-              <a:spcAft>
-                <a:spcPts val="200"/>
-              </a:spcAft>
-              <a:defRPr sz="1600">
-                <a:solidFill>
-                  <a:srgbClr val="555555"/>
-                </a:solidFill>
-              </a:defRPr>
-            </a:pPr>
-            <a:r>
-              <a:t>    – base64, leetspeak, ROT13, Unicode escape, character substitution — N × M coverage of every seed for free.</a:t>
-            </a:r>
-          </a:p>
-          <a:p>
-            <a:pPr>
-              <a:spcAft>
-                <a:spcPts val="600"/>
-              </a:spcAft>
-              <a:defRPr sz="2000">
-                <a:solidFill>
-                  <a:srgbClr val="1A2B4C"/>
-                </a:solidFill>
-              </a:defRPr>
-            </a:pPr>
-            <a:r>
-              <a:t>• Memory + scoring scaffolding.</a:t>
-            </a:r>
-          </a:p>
-          <a:p>
-            <a:pPr>
-              <a:spcAft>
-                <a:spcPts val="200"/>
-              </a:spcAft>
-              <a:defRPr sz="1600">
-                <a:solidFill>
-                  <a:srgbClr val="555555"/>
-                </a:solidFill>
-              </a:defRPr>
-            </a:pPr>
-            <a:r>
-              <a:t>    – Conversation memory, replay, and a scorer interface where our own Judge plugs in.</a:t>
-            </a:r>
-          </a:p>
-          <a:p>
-            <a:pPr>
-              <a:spcAft>
-                <a:spcPts val="600"/>
-              </a:spcAft>
-              <a:defRPr sz="2000">
-                <a:solidFill>
-                  <a:srgbClr val="1A2B4C"/>
-                </a:solidFill>
-              </a:defRPr>
-            </a:pPr>
-            <a:r>
-              <a:t>• Considered and rejected: Promptfoo (static eval, no multi-turn mutation), Garak (one-shot probing), rolling our own (~2 days reinventing TAP).</a:t>
+              <a:t>• Surfaced in the UI as an Escalation Policy card on /orchestrator with toggle + live trigger counts — not a hidden config.</a:t>
             </a:r>
           </a:p>
         </p:txBody>
@@ -8485,7 +8695,7 @@
               </a:defRPr>
             </a:pPr>
             <a:r>
-              <a:t>What we don't use from PyRIT: high-level agent coordination (LangGraph), Judge wrapping (own rubrics), or its CLI patterns (we wrap it as a service).</a:t>
+              <a:t>DeepSeek's published refusal rate on offensive prompts is materially lower than Claude / GPT / Gemini; that's the reason we picked it as escalation rather than another frontier API.</a:t>
             </a:r>
           </a:p>
         </p:txBody>
@@ -8581,7 +8791,7 @@
               </a:defRPr>
             </a:pPr>
             <a:r>
-              <a:t>Orchestration strategy — what gets tested next</a:t>
+              <a:t>Framework choice: PyRIT for attack orchestration</a:t>
             </a:r>
           </a:p>
         </p:txBody>
@@ -8619,7 +8829,37 @@
               </a:defRPr>
             </a:pPr>
             <a:r>
-              <a:t>• Coverage matrix: 6 categories × ~30 subcategories, each cell tracks cases-run, recent pass-rate, severity weight.</a:t>
+              <a:t>• Multi-turn mutation orchestrators built-in.</a:t>
+            </a:r>
+          </a:p>
+          <a:p>
+            <a:pPr>
+              <a:spcAft>
+                <a:spcPts val="200"/>
+              </a:spcAft>
+              <a:defRPr sz="1600">
+                <a:solidFill>
+                  <a:srgbClr val="555555"/>
+                </a:solidFill>
+              </a:defRPr>
+            </a:pPr>
+            <a:r>
+              <a:t>    – TreeOfAttacksWithPruningOrchestrator (TAP): attacker LLM generates → tests → refines based on target responses.</a:t>
+            </a:r>
+          </a:p>
+          <a:p>
+            <a:pPr>
+              <a:spcAft>
+                <a:spcPts val="200"/>
+              </a:spcAft>
+              <a:defRPr sz="1600">
+                <a:solidFill>
+                  <a:srgbClr val="555555"/>
+                </a:solidFill>
+              </a:defRPr>
+            </a:pPr>
+            <a:r>
+              <a:t>    – CrescendoOrchestrator: gradual multi-turn escalation. ~1000 lines we'd otherwise hand-write and tune.</a:t>
             </a:r>
           </a:p>
           <a:p>
@@ -8634,7 +8874,22 @@
               </a:defRPr>
             </a:pPr>
             <a:r>
-              <a:t>• Priority score per cell = severity × (1 − coverage_ratio) + 0.4 × recent_failure_rate + 0.3 × time_since_last.</a:t>
+              <a:t>• Battle-tested.</a:t>
+            </a:r>
+          </a:p>
+          <a:p>
+            <a:pPr>
+              <a:spcAft>
+                <a:spcPts val="200"/>
+              </a:spcAft>
+              <a:defRPr sz="1600">
+                <a:solidFill>
+                  <a:srgbClr val="555555"/>
+                </a:solidFill>
+              </a:defRPr>
+            </a:pPr>
+            <a:r>
+              <a:t>    – Microsoft's AI Red Team uses it against Copilot, Phi-3, 100+ internal operations. Published paper, MIT-licensed, ~3.8K stars.</a:t>
             </a:r>
           </a:p>
           <a:p>
@@ -8649,7 +8904,22 @@
               </a:defRPr>
             </a:pPr>
             <a:r>
-              <a:t>• Campaign halts when 30-attack rolling success rate &lt; 2% AND &gt; $5 spent.</a:t>
+              <a:t>• Pluggable target/attacker models.</a:t>
+            </a:r>
+          </a:p>
+          <a:p>
+            <a:pPr>
+              <a:spcAft>
+                <a:spcPts val="200"/>
+              </a:spcAft>
+              <a:defRPr sz="1600">
+                <a:solidFill>
+                  <a:srgbClr val="555555"/>
+                </a:solidFill>
+              </a:defRPr>
+            </a:pPr>
+            <a:r>
+              <a:t>    – Swap RunPod-hosted abliterated Llama → DeepSeek-R1 → anything else by config. Same orchestrator, any OpenAI-compatible endpoint.</a:t>
             </a:r>
           </a:p>
           <a:p>
@@ -8664,7 +8934,7 @@
               </a:defRPr>
             </a:pPr>
             <a:r>
-              <a:t>• Hard caps enforced in harness, not trusted to agent prompts:</a:t>
+              <a:t>• Built-in converters (prompt obfuscation).</a:t>
             </a:r>
           </a:p>
           <a:p>
@@ -8679,7 +8949,7 @@
               </a:defRPr>
             </a:pPr>
             <a:r>
-              <a:t>    – Per-campaign USD cap. Per-day global USD cap. Per-target QPS token-bucket.</a:t>
+              <a:t>    – base64, leetspeak, ROT13, Unicode escape, character substitution — N × M coverage of every seed for free.</a:t>
             </a:r>
           </a:p>
           <a:p>
@@ -8694,7 +8964,72 @@
               </a:defRPr>
             </a:pPr>
             <a:r>
-              <a:t>• Regression runs auto-trigger on target deploys (CircleCI pre-`hold-qa` job calls /regression-runs).</a:t>
+              <a:t>• Memory + scoring scaffolding.</a:t>
+            </a:r>
+          </a:p>
+          <a:p>
+            <a:pPr>
+              <a:spcAft>
+                <a:spcPts val="200"/>
+              </a:spcAft>
+              <a:defRPr sz="1600">
+                <a:solidFill>
+                  <a:srgbClr val="555555"/>
+                </a:solidFill>
+              </a:defRPr>
+            </a:pPr>
+            <a:r>
+              <a:t>    – Conversation memory, replay, and a scorer interface where our own Judge plugs in.</a:t>
+            </a:r>
+          </a:p>
+          <a:p>
+            <a:pPr>
+              <a:spcAft>
+                <a:spcPts val="600"/>
+              </a:spcAft>
+              <a:defRPr sz="2000">
+                <a:solidFill>
+                  <a:srgbClr val="1A2B4C"/>
+                </a:solidFill>
+              </a:defRPr>
+            </a:pPr>
+            <a:r>
+              <a:t>• Considered and rejected: Promptfoo (static eval, no multi-turn mutation), Garak (one-shot probing), rolling our own (~2 days reinventing TAP).</a:t>
+            </a:r>
+          </a:p>
+        </p:txBody>
+      </p:sp>
+      <p:sp>
+        <p:nvSpPr>
+          <p:cNvPr id="5" name="TextBox 4"/>
+          <p:cNvSpPr txBox="1"/>
+          <p:nvPr/>
+        </p:nvSpPr>
+        <p:spPr>
+          <a:xfrm>
+            <a:off x="457200" y="6355080"/>
+            <a:ext cx="11247120" cy="365760"/>
+          </a:xfrm>
+          <a:prstGeom prst="rect">
+            <a:avLst/>
+          </a:prstGeom>
+          <a:noFill/>
+        </p:spPr>
+        <p:txBody>
+          <a:bodyPr wrap="none">
+            <a:spAutoFit/>
+          </a:bodyPr>
+          <a:lstStyle/>
+          <a:p>
+            <a:pPr algn="l">
+              <a:defRPr sz="1100">
+                <a:solidFill>
+                  <a:srgbClr val="555555"/>
+                </a:solidFill>
+              </a:defRPr>
+            </a:pPr>
+            <a:r>
+              <a:t>What we don't use from PyRIT: high-level agent coordination (LangGraph), Judge wrapping (own rubrics), or its CLI patterns (we wrap it as a service).</a:t>
             </a:r>
           </a:p>
         </p:txBody>

</xml_diff>